<commit_message>
feat(apresentacao): slide de análise de erro da matriz de confusão (D1)
Adiciona slide 9 explicando por que a F1 do Desenho 1 é baixa, com figura nova
(precisão/recall/F1 vs limiar + RUS vs sem-RUS). Reproduz o modelo exato do deck
(matriz 492/375/35/64). Mensagem: não é bug — recall 0,65 com precisão 0,15 é
consequência da base rate de 10% + sinal fraco (AUC 0,63); sem RUS a acurácia
sobe a 90% mas o recall é zero. Deck agora com 18 slides.
</commit_message>
<xml_diff>
--- a/docs/apresentacoes/apresentacao_modelagem/Apresentacao_Modelagem_Ablacao_PNS2019.pptx
+++ b/docs/apresentacoes/apresentacao_modelagem/Apresentacao_Modelagem_Ablacao_PNS2019.pptx
@@ -22,9 +22,10 @@
     <p:sldId id="270" r:id="rId16"/>
     <p:sldId id="271" r:id="rId17"/>
     <p:sldId id="272" r:id="rId18"/>
+    <p:sldId id="273" r:id="rId19"/>
   </p:sldIdLst>
   <p:notesMasterIdLst>
-    <p:notesMasterId r:id="rId19"/>
+    <p:notesMasterId r:id="rId20"/>
   </p:notesMasterIdLst>
   <p:sldSz cx="12192000" cy="6858000"/>
   <p:notesSz cx="6858000" cy="12192000"/>
@@ -1246,6 +1247,94 @@
             <a:fld id="{F7021451-1387-4CA6-816F-3879F97B5CBC}" type="slidenum">
               <a:rPr lang="en-US"/>
               <a:t>17</a:t>
+            </a:fld>
+            <a:endParaRPr lang="en-US"/>
+          </a:p>
+        </p:txBody>
+      </p:sp>
+    </p:spTree>
+    <p:extLst>
+      <p:ext uri="{BB962C8B-B14F-4D97-AF65-F5344CB8AC3E}">
+        <p14:creationId xmlns:p14="http://schemas.microsoft.com/office/powerpoint/2010/main" val="1024086991"/>
+      </p:ext>
+    </p:extLst>
+  </p:cSld>
+  <p:clrMapOvr>
+    <a:masterClrMapping/>
+  </p:clrMapOvr>
+</p:notes>
+</file>
+
+<file path=ppt/notesSlides/notesSlide18.xml><?xml version="1.0" encoding="utf-8"?>
+<p:notes xmlns:a="http://schemas.openxmlformats.org/drawingml/2006/main" xmlns:r="http://schemas.openxmlformats.org/officeDocument/2006/relationships" xmlns:p="http://schemas.openxmlformats.org/presentationml/2006/main">
+  <p:cSld>
+    <p:spTree>
+      <p:nvGrpSpPr>
+        <p:cNvPr id="1" name=""/>
+        <p:cNvGrpSpPr/>
+        <p:nvPr/>
+      </p:nvGrpSpPr>
+      <p:grpSpPr>
+        <a:xfrm>
+          <a:off x="0" y="0"/>
+          <a:ext cx="0" cy="0"/>
+          <a:chOff x="0" y="0"/>
+          <a:chExt cx="0" cy="0"/>
+        </a:xfrm>
+      </p:grpSpPr>
+      <p:sp>
+        <p:nvSpPr>
+          <p:cNvPr id="2" name="Slide Image Placeholder 1"/>
+          <p:cNvSpPr>
+            <a:spLocks noGrp="1" noRot="1" noChangeAspect="1"/>
+          </p:cNvSpPr>
+          <p:nvPr>
+            <p:ph type="sldImg"/>
+          </p:nvPr>
+        </p:nvSpPr>
+        <p:spPr/>
+      </p:sp>
+      <p:sp>
+        <p:nvSpPr>
+          <p:cNvPr id="3" name="Notes Placeholder 2"/>
+          <p:cNvSpPr>
+            <a:spLocks noGrp="1"/>
+          </p:cNvSpPr>
+          <p:nvPr>
+            <p:ph type="body" idx="1"/>
+          </p:nvPr>
+        </p:nvSpPr>
+        <p:spPr/>
+        <p:txBody>
+          <a:bodyPr/>
+          <a:lstStyle/>
+          <a:p>
+            <a:r>
+              <a:rPr lang="en-US" dirty="0"/>
+              <a:t/>
+            </a:r>
+            <a:endParaRPr lang="en-US" dirty="0"/>
+          </a:p>
+        </p:txBody>
+      </p:sp>
+      <p:sp>
+        <p:nvSpPr>
+          <p:cNvPr id="4" name="Slide Number Placeholder 3"/>
+          <p:cNvSpPr>
+            <a:spLocks noGrp="1"/>
+          </p:cNvSpPr>
+          <p:nvPr>
+            <p:ph type="sldNum" sz="quarter" idx="10"/>
+          </p:nvPr>
+        </p:nvSpPr>
+        <p:spPr/>
+        <p:txBody>
+          <a:bodyPr/>
+          <a:lstStyle/>
+          <a:p>
+            <a:fld id="{F7021451-1387-4CA6-816F-3879F97B5CBC}" type="slidenum">
+              <a:rPr lang="en-US"/>
+              <a:t>18</a:t>
             </a:fld>
             <a:endParaRPr lang="en-US"/>
           </a:p>
@@ -2631,6 +2720,309 @@
                 <a:ea typeface="Calibri" pitchFamily="34" charset="-122"/>
                 <a:cs typeface="Calibri" pitchFamily="34" charset="-120"/>
               </a:rPr>
+              <a:t>RESULTADO 3 · IMPORTÂNCIA POR BLOCO (FLORESTA · M3)</a:t>
+            </a:r>
+            <a:endParaRPr lang="en-US" sz="1200" dirty="0"/>
+          </a:p>
+        </p:txBody>
+      </p:sp>
+      <p:sp>
+        <p:nvSpPr>
+          <p:cNvPr id="3" name="Text 1"/>
+          <p:cNvSpPr/>
+          <p:nvPr/>
+        </p:nvSpPr>
+        <p:spPr>
+          <a:xfrm>
+            <a:off x="640080" y="777240"/>
+            <a:ext cx="11155680" cy="868680"/>
+          </a:xfrm>
+          <a:prstGeom prst="rect">
+            <a:avLst/>
+          </a:prstGeom>
+          <a:noFill/>
+          <a:ln/>
+        </p:spPr>
+        <p:txBody>
+          <a:bodyPr wrap="square" lIns="0" tIns="0" rIns="0" bIns="0" rtlCol="0" anchor="ctr"/>
+          <a:lstStyle/>
+          <a:p>
+            <a:pPr indent="0" marL="0">
+              <a:buNone/>
+            </a:pPr>
+            <a:r>
+              <a:rPr lang="en-US" sz="3000" b="1" dirty="0">
+                <a:solidFill>
+                  <a:srgbClr val="1E2761"/>
+                </a:solidFill>
+                <a:latin typeface="Georgia" pitchFamily="34" charset="0"/>
+                <a:ea typeface="Georgia" pitchFamily="34" charset="-122"/>
+                <a:cs typeface="Georgia" pitchFamily="34" charset="-120"/>
+              </a:rPr>
+              <a:t>O topo do ranking é sexo e saúde, não comida</a:t>
+            </a:r>
+            <a:endParaRPr lang="en-US" sz="3000" dirty="0"/>
+          </a:p>
+        </p:txBody>
+      </p:sp>
+      <p:pic>
+        <p:nvPicPr>
+          <p:cNvPr id="4" name="Image 0" descr="figuras/modelagem_importancia_bloco.png">    </p:cNvPr>
+          <p:cNvPicPr>
+            <a:picLocks noChangeAspect="1"/>
+          </p:cNvPicPr>
+          <p:nvPr/>
+        </p:nvPicPr>
+        <p:blipFill>
+          <a:blip r:embed="rId1"/>
+          <a:stretch>
+            <a:fillRect/>
+          </a:stretch>
+        </p:blipFill>
+        <p:spPr>
+          <a:xfrm>
+            <a:off x="1280160" y="1737360"/>
+            <a:ext cx="9601200" cy="3840480"/>
+          </a:xfrm>
+          <a:prstGeom prst="rect">
+            <a:avLst/>
+          </a:prstGeom>
+          <a:effectLst>
+            <a:outerShdw sx="100000" sy="100000" kx="0" ky="0" algn="bl" rotWithShape="0" blurRad="88900" dist="38100" dir="8100000">
+              <a:srgbClr val="000000">
+                <a:alpha val="16000"/>
+              </a:srgbClr>
+            </a:outerShdw>
+          </a:effectLst>
+        </p:spPr>
+      </p:pic>
+      <p:sp>
+        <p:nvSpPr>
+          <p:cNvPr id="5" name="Shape 2"/>
+          <p:cNvSpPr/>
+          <p:nvPr/>
+        </p:nvSpPr>
+        <p:spPr>
+          <a:xfrm>
+            <a:off x="640080" y="5760720"/>
+            <a:ext cx="10881360" cy="713232"/>
+          </a:xfrm>
+          <a:prstGeom prst="rect">
+            <a:avLst/>
+          </a:prstGeom>
+          <a:solidFill>
+            <a:srgbClr val="EEF6F0"/>
+          </a:solidFill>
+          <a:ln w="12700">
+            <a:solidFill>
+              <a:srgbClr val="2980B9"/>
+            </a:solidFill>
+            <a:prstDash val="solid"/>
+          </a:ln>
+        </p:spPr>
+      </p:sp>
+      <p:sp>
+        <p:nvSpPr>
+          <p:cNvPr id="6" name="Text 3"/>
+          <p:cNvSpPr/>
+          <p:nvPr/>
+        </p:nvSpPr>
+        <p:spPr>
+          <a:xfrm>
+            <a:off x="868680" y="5797296"/>
+            <a:ext cx="10424160" cy="640080"/>
+          </a:xfrm>
+          <a:prstGeom prst="rect">
+            <a:avLst/>
+          </a:prstGeom>
+          <a:noFill/>
+          <a:ln/>
+        </p:spPr>
+        <p:txBody>
+          <a:bodyPr wrap="square" lIns="0" tIns="0" rIns="0" bIns="0" rtlCol="0" anchor="ctr"/>
+          <a:lstStyle/>
+          <a:p>
+            <a:pPr indent="0" marL="0">
+              <a:lnSpc>
+                <a:spcPct val="106000"/>
+              </a:lnSpc>
+              <a:buNone/>
+            </a:pPr>
+            <a:r>
+              <a:rPr lang="en-US" sz="1300" b="1" dirty="0">
+                <a:solidFill>
+                  <a:srgbClr val="2980B9"/>
+                </a:solidFill>
+                <a:latin typeface="Calibri" pitchFamily="34" charset="0"/>
+                <a:ea typeface="Calibri" pitchFamily="34" charset="-122"/>
+                <a:cs typeface="Calibri" pitchFamily="34" charset="-120"/>
+              </a:rPr>
+              <a:t>O que isso significa:  </a:t>
+            </a:r>
+            <a:pPr indent="0" marL="0">
+              <a:lnSpc>
+                <a:spcPct val="106000"/>
+              </a:lnSpc>
+              <a:buNone/>
+            </a:pPr>
+            <a:r>
+              <a:rPr lang="en-US" sz="1300" dirty="0">
+                <a:solidFill>
+                  <a:srgbClr val="2B2B2B"/>
+                </a:solidFill>
+                <a:latin typeface="Calibri" pitchFamily="34" charset="0"/>
+                <a:ea typeface="Calibri" pitchFamily="34" charset="-122"/>
+                <a:cs typeface="Calibri" pitchFamily="34" charset="-120"/>
+              </a:rPr>
+              <a:t>as variáveis de maior importância são de CONTROLE (autoavaliação de saúde, consultas, problema de coluna) e SOCIO (sexo, azul). As verdes (nutrição) aparecem no fim — coerente com a entropia (§3) e com o Δ ≈ 0.</a:t>
+            </a:r>
+            <a:endParaRPr lang="en-US" sz="1300" dirty="0"/>
+          </a:p>
+        </p:txBody>
+      </p:sp>
+      <p:sp>
+        <p:nvSpPr>
+          <p:cNvPr id="7" name="Text 4"/>
+          <p:cNvSpPr/>
+          <p:nvPr/>
+        </p:nvSpPr>
+        <p:spPr>
+          <a:xfrm>
+            <a:off x="640080" y="6473952"/>
+            <a:ext cx="8229600" cy="274320"/>
+          </a:xfrm>
+          <a:prstGeom prst="rect">
+            <a:avLst/>
+          </a:prstGeom>
+          <a:noFill/>
+          <a:ln/>
+        </p:spPr>
+        <p:txBody>
+          <a:bodyPr wrap="square" lIns="0" tIns="0" rIns="0" bIns="0" rtlCol="0" anchor="ctr"/>
+          <a:lstStyle/>
+          <a:p>
+            <a:pPr indent="0" marL="0">
+              <a:buNone/>
+            </a:pPr>
+            <a:r>
+              <a:rPr lang="en-US" sz="900" dirty="0">
+                <a:solidFill>
+                  <a:srgbClr val="6B7280"/>
+                </a:solidFill>
+                <a:latin typeface="Calibri" pitchFamily="34" charset="0"/>
+                <a:ea typeface="Calibri" pitchFamily="34" charset="-122"/>
+                <a:cs typeface="Calibri" pitchFamily="34" charset="-120"/>
+              </a:rPr>
+              <a:t>NB06 §4 · Ablação por blocos — PNS 2019 · Artrite em idosos ≥60</a:t>
+            </a:r>
+            <a:endParaRPr lang="en-US" sz="900" dirty="0"/>
+          </a:p>
+        </p:txBody>
+      </p:sp>
+      <p:sp>
+        <p:nvSpPr>
+          <p:cNvPr id="8" name="Text 5"/>
+          <p:cNvSpPr/>
+          <p:nvPr/>
+        </p:nvSpPr>
+        <p:spPr>
+          <a:xfrm>
+            <a:off x="11247120" y="6473952"/>
+            <a:ext cx="365760" cy="274320"/>
+          </a:xfrm>
+          <a:prstGeom prst="rect">
+            <a:avLst/>
+          </a:prstGeom>
+          <a:noFill/>
+          <a:ln/>
+        </p:spPr>
+        <p:txBody>
+          <a:bodyPr wrap="square" lIns="0" tIns="0" rIns="0" bIns="0" rtlCol="0" anchor="ctr"/>
+          <a:lstStyle/>
+          <a:p>
+            <a:pPr algn="r" indent="0" marL="0">
+              <a:buNone/>
+            </a:pPr>
+            <a:r>
+              <a:rPr lang="en-US" sz="900" dirty="0">
+                <a:solidFill>
+                  <a:srgbClr val="6B7280"/>
+                </a:solidFill>
+                <a:latin typeface="Calibri" pitchFamily="34" charset="0"/>
+                <a:ea typeface="Calibri" pitchFamily="34" charset="-122"/>
+                <a:cs typeface="Calibri" pitchFamily="34" charset="-120"/>
+              </a:rPr>
+              <a:t>9</a:t>
+            </a:r>
+            <a:endParaRPr lang="en-US" sz="900" dirty="0"/>
+          </a:p>
+        </p:txBody>
+      </p:sp>
+    </p:spTree>
+  </p:cSld>
+  <p:clrMapOvr>
+    <a:masterClrMapping/>
+  </p:clrMapOvr>
+</p:sld>
+</file>
+
+<file path=ppt/slides/slide11.xml><?xml version="1.0" encoding="utf-8"?>
+<p:sld xmlns:a="http://schemas.openxmlformats.org/drawingml/2006/main" xmlns:r="http://schemas.openxmlformats.org/officeDocument/2006/relationships" xmlns:p="http://schemas.openxmlformats.org/presentationml/2006/main">
+  <p:cSld name="Slide 11">
+    <p:bg>
+      <p:bgPr>
+        <a:solidFill>
+          <a:srgbClr val="FFFFFF"/>
+        </a:solidFill>
+      </p:bgPr>
+    </p:bg>
+    <p:spTree>
+      <p:nvGrpSpPr>
+        <p:cNvPr id="1" name=""/>
+        <p:cNvGrpSpPr/>
+        <p:nvPr/>
+      </p:nvGrpSpPr>
+      <p:grpSpPr>
+        <a:xfrm>
+          <a:off x="0" y="0"/>
+          <a:ext cx="0" cy="0"/>
+          <a:chOff x="0" y="0"/>
+          <a:chExt cx="0" cy="0"/>
+        </a:xfrm>
+      </p:grpSpPr>
+      <p:sp>
+        <p:nvSpPr>
+          <p:cNvPr id="2" name="Text 0"/>
+          <p:cNvSpPr/>
+          <p:nvPr/>
+        </p:nvSpPr>
+        <p:spPr>
+          <a:xfrm>
+            <a:off x="640080" y="457200"/>
+            <a:ext cx="10972800" cy="292608"/>
+          </a:xfrm>
+          <a:prstGeom prst="rect">
+            <a:avLst/>
+          </a:prstGeom>
+          <a:noFill/>
+          <a:ln/>
+        </p:spPr>
+        <p:txBody>
+          <a:bodyPr wrap="square" lIns="0" tIns="0" rIns="0" bIns="0" rtlCol="0" anchor="ctr"/>
+          <a:lstStyle/>
+          <a:p>
+            <a:pPr indent="0" marL="0">
+              <a:buNone/>
+            </a:pPr>
+            <a:r>
+              <a:rPr lang="en-US" sz="1200" b="1" spc="300" kern="0" dirty="0">
+                <a:solidFill>
+                  <a:srgbClr val="E8A33D"/>
+                </a:solidFill>
+                <a:latin typeface="Calibri" pitchFamily="34" charset="0"/>
+                <a:ea typeface="Calibri" pitchFamily="34" charset="-122"/>
+                <a:cs typeface="Calibri" pitchFamily="34" charset="-120"/>
+              </a:rPr>
               <a:t>RESULTADO 4 · ODDS RATIO AJUSTADO (DIETA NET DE SOCIO)</a:t>
             </a:r>
             <a:endParaRPr lang="en-US" sz="1200" dirty="0"/>
@@ -2678,7 +3070,7 @@
       </p:sp>
       <p:graphicFrame>
         <p:nvGraphicFramePr>
-          <p:cNvPr id="11" name="Table 0"/>
+          <p:cNvPr id="12" name="Table 0"/>
           <p:cNvGraphicFramePr>
             <a:graphicFrameLocks noGrp="1"/>
           </p:cNvGraphicFramePr>
@@ -4273,654 +4665,6 @@
                 <a:ea typeface="Calibri" pitchFamily="34" charset="-122"/>
                 <a:cs typeface="Calibri" pitchFamily="34" charset="-120"/>
               </a:rPr>
-              <a:t>9</a:t>
-            </a:r>
-            <a:endParaRPr lang="en-US" sz="900" dirty="0"/>
-          </a:p>
-        </p:txBody>
-      </p:sp>
-    </p:spTree>
-  </p:cSld>
-  <p:clrMapOvr>
-    <a:masterClrMapping/>
-  </p:clrMapOvr>
-</p:sld>
-</file>
-
-<file path=ppt/slides/slide11.xml><?xml version="1.0" encoding="utf-8"?>
-<p:sld xmlns:a="http://schemas.openxmlformats.org/drawingml/2006/main" xmlns:r="http://schemas.openxmlformats.org/officeDocument/2006/relationships" xmlns:p="http://schemas.openxmlformats.org/presentationml/2006/main">
-  <p:cSld name="Slide 11">
-    <p:bg>
-      <p:bgPr>
-        <a:solidFill>
-          <a:srgbClr val="FFFFFF"/>
-        </a:solidFill>
-      </p:bgPr>
-    </p:bg>
-    <p:spTree>
-      <p:nvGrpSpPr>
-        <p:cNvPr id="1" name=""/>
-        <p:cNvGrpSpPr/>
-        <p:nvPr/>
-      </p:nvGrpSpPr>
-      <p:grpSpPr>
-        <a:xfrm>
-          <a:off x="0" y="0"/>
-          <a:ext cx="0" cy="0"/>
-          <a:chOff x="0" y="0"/>
-          <a:chExt cx="0" cy="0"/>
-        </a:xfrm>
-      </p:grpSpPr>
-      <p:sp>
-        <p:nvSpPr>
-          <p:cNvPr id="2" name="Text 0"/>
-          <p:cNvSpPr/>
-          <p:nvPr/>
-        </p:nvSpPr>
-        <p:spPr>
-          <a:xfrm>
-            <a:off x="640080" y="457200"/>
-            <a:ext cx="10972800" cy="292608"/>
-          </a:xfrm>
-          <a:prstGeom prst="rect">
-            <a:avLst/>
-          </a:prstGeom>
-          <a:noFill/>
-          <a:ln/>
-        </p:spPr>
-        <p:txBody>
-          <a:bodyPr wrap="square" lIns="0" tIns="0" rIns="0" bIns="0" rtlCol="0" anchor="ctr"/>
-          <a:lstStyle/>
-          <a:p>
-            <a:pPr indent="0" marL="0">
-              <a:buNone/>
-            </a:pPr>
-            <a:r>
-              <a:rPr lang="en-US" sz="1200" b="1" spc="300" kern="0" dirty="0">
-                <a:solidFill>
-                  <a:srgbClr val="E8A33D"/>
-                </a:solidFill>
-                <a:latin typeface="Calibri" pitchFamily="34" charset="0"/>
-                <a:ea typeface="Calibri" pitchFamily="34" charset="-122"/>
-                <a:cs typeface="Calibri" pitchFamily="34" charset="-120"/>
-              </a:rPr>
-              <a:t>RESULTADO 5 · REGRAS DA ÁRVORE (COBERTURA ≥ 10%)</a:t>
-            </a:r>
-            <a:endParaRPr lang="en-US" sz="1200" dirty="0"/>
-          </a:p>
-        </p:txBody>
-      </p:sp>
-      <p:sp>
-        <p:nvSpPr>
-          <p:cNvPr id="3" name="Text 1"/>
-          <p:cNvSpPr/>
-          <p:nvPr/>
-        </p:nvSpPr>
-        <p:spPr>
-          <a:xfrm>
-            <a:off x="640080" y="777240"/>
-            <a:ext cx="11155680" cy="868680"/>
-          </a:xfrm>
-          <a:prstGeom prst="rect">
-            <a:avLst/>
-          </a:prstGeom>
-          <a:noFill/>
-          <a:ln/>
-        </p:spPr>
-        <p:txBody>
-          <a:bodyPr wrap="square" lIns="0" tIns="0" rIns="0" bIns="0" rtlCol="0" anchor="ctr"/>
-          <a:lstStyle/>
-          <a:p>
-            <a:pPr indent="0" marL="0">
-              <a:buNone/>
-            </a:pPr>
-            <a:r>
-              <a:rPr lang="en-US" sz="3000" b="1" dirty="0">
-                <a:solidFill>
-                  <a:srgbClr val="1E2761"/>
-                </a:solidFill>
-                <a:latin typeface="Georgia" pitchFamily="34" charset="0"/>
-                <a:ea typeface="Georgia" pitchFamily="34" charset="-122"/>
-                <a:cs typeface="Georgia" pitchFamily="34" charset="-120"/>
-              </a:rPr>
-              <a:t>As regras descrevem perfil, não dieta</a:t>
-            </a:r>
-            <a:endParaRPr lang="en-US" sz="3000" dirty="0"/>
-          </a:p>
-        </p:txBody>
-      </p:sp>
-      <p:sp>
-        <p:nvSpPr>
-          <p:cNvPr id="4" name="Shape 2"/>
-          <p:cNvSpPr/>
-          <p:nvPr/>
-        </p:nvSpPr>
-        <p:spPr>
-          <a:xfrm>
-            <a:off x="640080" y="1783080"/>
-            <a:ext cx="10881360" cy="1463040"/>
-          </a:xfrm>
-          <a:prstGeom prst="rect">
-            <a:avLst/>
-          </a:prstGeom>
-          <a:solidFill>
-            <a:srgbClr val="F4F6FB"/>
-          </a:solidFill>
-          <a:ln w="12700">
-            <a:solidFill>
-              <a:srgbClr val="E3E8F5"/>
-            </a:solidFill>
-            <a:prstDash val="solid"/>
-          </a:ln>
-          <a:effectLst>
-            <a:outerShdw sx="100000" sy="100000" kx="0" ky="0" algn="bl" rotWithShape="0" blurRad="88900" dist="38100" dir="8100000">
-              <a:srgbClr val="000000">
-                <a:alpha val="16000"/>
-              </a:srgbClr>
-            </a:outerShdw>
-          </a:effectLst>
-        </p:spPr>
-      </p:sp>
-      <p:sp>
-        <p:nvSpPr>
-          <p:cNvPr id="5" name="Shape 3"/>
-          <p:cNvSpPr/>
-          <p:nvPr/>
-        </p:nvSpPr>
-        <p:spPr>
-          <a:xfrm>
-            <a:off x="640080" y="1783080"/>
-            <a:ext cx="82296" cy="1463040"/>
-          </a:xfrm>
-          <a:prstGeom prst="rect">
-            <a:avLst/>
-          </a:prstGeom>
-          <a:solidFill>
-            <a:srgbClr val="27AE60"/>
-          </a:solidFill>
-          <a:ln/>
-        </p:spPr>
-      </p:sp>
-      <p:sp>
-        <p:nvSpPr>
-          <p:cNvPr id="6" name="Text 4"/>
-          <p:cNvSpPr/>
-          <p:nvPr/>
-        </p:nvSpPr>
-        <p:spPr>
-          <a:xfrm>
-            <a:off x="914400" y="1920240"/>
-            <a:ext cx="10058400" cy="365760"/>
-          </a:xfrm>
-          <a:prstGeom prst="rect">
-            <a:avLst/>
-          </a:prstGeom>
-          <a:noFill/>
-          <a:ln/>
-        </p:spPr>
-        <p:txBody>
-          <a:bodyPr wrap="square" lIns="0" tIns="0" rIns="0" bIns="0" rtlCol="0" anchor="ctr"/>
-          <a:lstStyle/>
-          <a:p>
-            <a:pPr indent="0" marL="0">
-              <a:buNone/>
-            </a:pPr>
-            <a:r>
-              <a:rPr lang="en-US" sz="1450" b="1" dirty="0">
-                <a:solidFill>
-                  <a:srgbClr val="27AE60"/>
-                </a:solidFill>
-                <a:latin typeface="Georgia" pitchFamily="34" charset="0"/>
-                <a:ea typeface="Georgia" pitchFamily="34" charset="-122"/>
-                <a:cs typeface="Georgia" pitchFamily="34" charset="-120"/>
-              </a:rPr>
-              <a:t>Desenho 1 — perfil SAUDÁVEL (pureza ≈ 0,95)</a:t>
-            </a:r>
-            <a:endParaRPr lang="en-US" sz="1450" dirty="0"/>
-          </a:p>
-        </p:txBody>
-      </p:sp>
-      <p:sp>
-        <p:nvSpPr>
-          <p:cNvPr id="7" name="Text 5"/>
-          <p:cNvSpPr/>
-          <p:nvPr/>
-        </p:nvSpPr>
-        <p:spPr>
-          <a:xfrm>
-            <a:off x="914400" y="2377440"/>
-            <a:ext cx="10058400" cy="731520"/>
-          </a:xfrm>
-          <a:prstGeom prst="rect">
-            <a:avLst/>
-          </a:prstGeom>
-          <a:noFill/>
-          <a:ln/>
-        </p:spPr>
-        <p:txBody>
-          <a:bodyPr wrap="square" lIns="0" tIns="0" rIns="0" bIns="0" rtlCol="0" anchor="ctr"/>
-          <a:lstStyle/>
-          <a:p>
-            <a:pPr indent="0" marL="0">
-              <a:lnSpc>
-                <a:spcPct val="110000"/>
-              </a:lnSpc>
-              <a:buNone/>
-            </a:pPr>
-            <a:r>
-              <a:rPr lang="en-US" sz="1350" b="1" dirty="0">
-                <a:solidFill>
-                  <a:srgbClr val="6B7280"/>
-                </a:solidFill>
-                <a:latin typeface="Calibri" pitchFamily="34" charset="0"/>
-                <a:ea typeface="Calibri" pitchFamily="34" charset="-122"/>
-                <a:cs typeface="Calibri" pitchFamily="34" charset="-120"/>
-              </a:rPr>
-              <a:t>SE  </a:t>
-            </a:r>
-            <a:pPr indent="0" marL="0">
-              <a:lnSpc>
-                <a:spcPct val="110000"/>
-              </a:lnSpc>
-              <a:buNone/>
-            </a:pPr>
-            <a:r>
-              <a:rPr lang="en-US" sz="1350" dirty="0">
-                <a:solidFill>
-                  <a:srgbClr val="2B2B2B"/>
-                </a:solidFill>
-                <a:latin typeface="Calibri" pitchFamily="34" charset="0"/>
-                <a:ea typeface="Calibri" pitchFamily="34" charset="-122"/>
-                <a:cs typeface="Calibri" pitchFamily="34" charset="-120"/>
-              </a:rPr>
-              <a:t>homem  E  come feijão (≥ faixa)  E  mais escolaridade</a:t>
-            </a:r>
-            <a:pPr indent="0" marL="0">
-              <a:lnSpc>
-                <a:spcPct val="110000"/>
-              </a:lnSpc>
-              <a:buNone/>
-            </a:pPr>
-            <a:r>
-              <a:rPr lang="en-US" sz="1350" b="1" dirty="0">
-                <a:solidFill>
-                  <a:srgbClr val="27AE60"/>
-                </a:solidFill>
-                <a:latin typeface="Calibri" pitchFamily="34" charset="0"/>
-                <a:ea typeface="Calibri" pitchFamily="34" charset="-122"/>
-                <a:cs typeface="Calibri" pitchFamily="34" charset="-120"/>
-              </a:rPr>
-              <a:t>   → Saudável   (cobre 12%).</a:t>
-            </a:r>
-            <a:endParaRPr lang="en-US" sz="1350" dirty="0"/>
-          </a:p>
-        </p:txBody>
-      </p:sp>
-      <p:sp>
-        <p:nvSpPr>
-          <p:cNvPr id="8" name="Shape 6"/>
-          <p:cNvSpPr/>
-          <p:nvPr/>
-        </p:nvSpPr>
-        <p:spPr>
-          <a:xfrm>
-            <a:off x="640080" y="3429000"/>
-            <a:ext cx="10881360" cy="1920240"/>
-          </a:xfrm>
-          <a:prstGeom prst="rect">
-            <a:avLst/>
-          </a:prstGeom>
-          <a:solidFill>
-            <a:srgbClr val="F4F6FB"/>
-          </a:solidFill>
-          <a:ln w="12700">
-            <a:solidFill>
-              <a:srgbClr val="E3E8F5"/>
-            </a:solidFill>
-            <a:prstDash val="solid"/>
-          </a:ln>
-          <a:effectLst>
-            <a:outerShdw sx="100000" sy="100000" kx="0" ky="0" algn="bl" rotWithShape="0" blurRad="88900" dist="38100" dir="8100000">
-              <a:srgbClr val="000000">
-                <a:alpha val="16000"/>
-              </a:srgbClr>
-            </a:outerShdw>
-          </a:effectLst>
-        </p:spPr>
-      </p:sp>
-      <p:sp>
-        <p:nvSpPr>
-          <p:cNvPr id="9" name="Shape 7"/>
-          <p:cNvSpPr/>
-          <p:nvPr/>
-        </p:nvSpPr>
-        <p:spPr>
-          <a:xfrm>
-            <a:off x="640080" y="3429000"/>
-            <a:ext cx="82296" cy="1920240"/>
-          </a:xfrm>
-          <a:prstGeom prst="rect">
-            <a:avLst/>
-          </a:prstGeom>
-          <a:solidFill>
-            <a:srgbClr val="C0392B"/>
-          </a:solidFill>
-          <a:ln/>
-        </p:spPr>
-      </p:sp>
-      <p:sp>
-        <p:nvSpPr>
-          <p:cNvPr id="10" name="Text 8"/>
-          <p:cNvSpPr/>
-          <p:nvPr/>
-        </p:nvSpPr>
-        <p:spPr>
-          <a:xfrm>
-            <a:off x="914400" y="3566160"/>
-            <a:ext cx="10058400" cy="365760"/>
-          </a:xfrm>
-          <a:prstGeom prst="rect">
-            <a:avLst/>
-          </a:prstGeom>
-          <a:noFill/>
-          <a:ln/>
-        </p:spPr>
-        <p:txBody>
-          <a:bodyPr wrap="square" lIns="0" tIns="0" rIns="0" bIns="0" rtlCol="0" anchor="ctr"/>
-          <a:lstStyle/>
-          <a:p>
-            <a:pPr indent="0" marL="0">
-              <a:buNone/>
-            </a:pPr>
-            <a:r>
-              <a:rPr lang="en-US" sz="1450" b="1" dirty="0">
-                <a:solidFill>
-                  <a:srgbClr val="C0392B"/>
-                </a:solidFill>
-                <a:latin typeface="Georgia" pitchFamily="34" charset="0"/>
-                <a:ea typeface="Georgia" pitchFamily="34" charset="-122"/>
-                <a:cs typeface="Georgia" pitchFamily="34" charset="-120"/>
-              </a:rPr>
-              <a:t>Desenho 2 — perfil ARTRITE</a:t>
-            </a:r>
-            <a:endParaRPr lang="en-US" sz="1450" dirty="0"/>
-          </a:p>
-        </p:txBody>
-      </p:sp>
-      <p:sp>
-        <p:nvSpPr>
-          <p:cNvPr id="11" name="Text 9"/>
-          <p:cNvSpPr/>
-          <p:nvPr/>
-        </p:nvSpPr>
-        <p:spPr>
-          <a:xfrm>
-            <a:off x="914400" y="3977640"/>
-            <a:ext cx="10058400" cy="640080"/>
-          </a:xfrm>
-          <a:prstGeom prst="rect">
-            <a:avLst/>
-          </a:prstGeom>
-          <a:noFill/>
-          <a:ln/>
-        </p:spPr>
-        <p:txBody>
-          <a:bodyPr wrap="square" lIns="0" tIns="0" rIns="0" bIns="0" rtlCol="0" anchor="ctr"/>
-          <a:lstStyle/>
-          <a:p>
-            <a:pPr indent="0" marL="0">
-              <a:lnSpc>
-                <a:spcPct val="110000"/>
-              </a:lnSpc>
-              <a:buNone/>
-            </a:pPr>
-            <a:r>
-              <a:rPr lang="en-US" sz="1350" b="1" dirty="0">
-                <a:solidFill>
-                  <a:srgbClr val="6B7280"/>
-                </a:solidFill>
-                <a:latin typeface="Calibri" pitchFamily="34" charset="0"/>
-                <a:ea typeface="Calibri" pitchFamily="34" charset="-122"/>
-                <a:cs typeface="Calibri" pitchFamily="34" charset="-120"/>
-              </a:rPr>
-              <a:t>SE  </a:t>
-            </a:r>
-            <a:pPr indent="0" marL="0">
-              <a:lnSpc>
-                <a:spcPct val="110000"/>
-              </a:lnSpc>
-              <a:buNone/>
-            </a:pPr>
-            <a:r>
-              <a:rPr lang="en-US" sz="1350" dirty="0">
-                <a:solidFill>
-                  <a:srgbClr val="2B2B2B"/>
-                </a:solidFill>
-                <a:latin typeface="Calibri" pitchFamily="34" charset="0"/>
-                <a:ea typeface="Calibri" pitchFamily="34" charset="-122"/>
-                <a:cs typeface="Calibri" pitchFamily="34" charset="-120"/>
-              </a:rPr>
-              <a:t>mulher  E  60–69 anos  E  menor escolaridade  E  IRNI &gt; −4,5</a:t>
-            </a:r>
-            <a:pPr indent="0" marL="0">
-              <a:lnSpc>
-                <a:spcPct val="110000"/>
-              </a:lnSpc>
-              <a:buNone/>
-            </a:pPr>
-            <a:r>
-              <a:rPr lang="en-US" sz="1350" b="1" dirty="0">
-                <a:solidFill>
-                  <a:srgbClr val="C0392B"/>
-                </a:solidFill>
-                <a:latin typeface="Calibri" pitchFamily="34" charset="0"/>
-                <a:ea typeface="Calibri" pitchFamily="34" charset="-122"/>
-                <a:cs typeface="Calibri" pitchFamily="34" charset="-120"/>
-              </a:rPr>
-              <a:t>   → Artrite   (cobre 20%, pureza 0,56).</a:t>
-            </a:r>
-            <a:endParaRPr lang="en-US" sz="1350" dirty="0"/>
-          </a:p>
-        </p:txBody>
-      </p:sp>
-      <p:sp>
-        <p:nvSpPr>
-          <p:cNvPr id="12" name="Text 10"/>
-          <p:cNvSpPr/>
-          <p:nvPr/>
-        </p:nvSpPr>
-        <p:spPr>
-          <a:xfrm>
-            <a:off x="914400" y="4572000"/>
-            <a:ext cx="10058400" cy="640080"/>
-          </a:xfrm>
-          <a:prstGeom prst="rect">
-            <a:avLst/>
-          </a:prstGeom>
-          <a:noFill/>
-          <a:ln/>
-        </p:spPr>
-        <p:txBody>
-          <a:bodyPr wrap="square" lIns="0" tIns="0" rIns="0" bIns="0" rtlCol="0" anchor="ctr"/>
-          <a:lstStyle/>
-          <a:p>
-            <a:pPr indent="0" marL="0">
-              <a:lnSpc>
-                <a:spcPct val="110000"/>
-              </a:lnSpc>
-              <a:buNone/>
-            </a:pPr>
-            <a:r>
-              <a:rPr lang="en-US" sz="1200" i="1" dirty="0">
-                <a:solidFill>
-                  <a:srgbClr val="2B2B2B"/>
-                </a:solidFill>
-                <a:latin typeface="Calibri" pitchFamily="34" charset="0"/>
-                <a:ea typeface="Calibri" pitchFamily="34" charset="-122"/>
-                <a:cs typeface="Calibri" pitchFamily="34" charset="-120"/>
-              </a:rPr>
-              <a:t>As variáveis nutricionais (feijão, sal, tipo de leite, IRNI) entram como ramos secundários — nunca como o eixo da regra. O eixo é sexo + idade + escolaridade.</a:t>
-            </a:r>
-            <a:endParaRPr lang="en-US" sz="1200" dirty="0"/>
-          </a:p>
-        </p:txBody>
-      </p:sp>
-      <p:sp>
-        <p:nvSpPr>
-          <p:cNvPr id="13" name="Shape 11"/>
-          <p:cNvSpPr/>
-          <p:nvPr/>
-        </p:nvSpPr>
-        <p:spPr>
-          <a:xfrm>
-            <a:off x="640080" y="5532120"/>
-            <a:ext cx="10881360" cy="713232"/>
-          </a:xfrm>
-          <a:prstGeom prst="rect">
-            <a:avLst/>
-          </a:prstGeom>
-          <a:solidFill>
-            <a:srgbClr val="EEF6F0"/>
-          </a:solidFill>
-          <a:ln w="12700">
-            <a:solidFill>
-              <a:srgbClr val="1E2761"/>
-            </a:solidFill>
-            <a:prstDash val="solid"/>
-          </a:ln>
-        </p:spPr>
-      </p:sp>
-      <p:sp>
-        <p:nvSpPr>
-          <p:cNvPr id="14" name="Text 12"/>
-          <p:cNvSpPr/>
-          <p:nvPr/>
-        </p:nvSpPr>
-        <p:spPr>
-          <a:xfrm>
-            <a:off x="868680" y="5568696"/>
-            <a:ext cx="10424160" cy="640080"/>
-          </a:xfrm>
-          <a:prstGeom prst="rect">
-            <a:avLst/>
-          </a:prstGeom>
-          <a:noFill/>
-          <a:ln/>
-        </p:spPr>
-        <p:txBody>
-          <a:bodyPr wrap="square" lIns="0" tIns="0" rIns="0" bIns="0" rtlCol="0" anchor="ctr"/>
-          <a:lstStyle/>
-          <a:p>
-            <a:pPr indent="0" marL="0">
-              <a:lnSpc>
-                <a:spcPct val="106000"/>
-              </a:lnSpc>
-              <a:buNone/>
-            </a:pPr>
-            <a:r>
-              <a:rPr lang="en-US" sz="1300" b="1" dirty="0">
-                <a:solidFill>
-                  <a:srgbClr val="1E2761"/>
-                </a:solidFill>
-                <a:latin typeface="Calibri" pitchFamily="34" charset="0"/>
-                <a:ea typeface="Calibri" pitchFamily="34" charset="-122"/>
-                <a:cs typeface="Calibri" pitchFamily="34" charset="-120"/>
-              </a:rPr>
-              <a:t>O que isso significa:  </a:t>
-            </a:r>
-            <a:pPr indent="0" marL="0">
-              <a:lnSpc>
-                <a:spcPct val="106000"/>
-              </a:lnSpc>
-              <a:buNone/>
-            </a:pPr>
-            <a:r>
-              <a:rPr lang="en-US" sz="1300" dirty="0">
-                <a:solidFill>
-                  <a:srgbClr val="2B2B2B"/>
-                </a:solidFill>
-                <a:latin typeface="Calibri" pitchFamily="34" charset="0"/>
-                <a:ea typeface="Calibri" pitchFamily="34" charset="-122"/>
-                <a:cs typeface="Calibri" pitchFamily="34" charset="-120"/>
-              </a:rPr>
-              <a:t>mesmo no modelo de regras (a entrega descritiva do estilo LICAP), a dieta é coadjuvante: as folhas de maior cobertura são definidas por características da pessoa.</a:t>
-            </a:r>
-            <a:endParaRPr lang="en-US" sz="1300" dirty="0"/>
-          </a:p>
-        </p:txBody>
-      </p:sp>
-      <p:sp>
-        <p:nvSpPr>
-          <p:cNvPr id="15" name="Text 13"/>
-          <p:cNvSpPr/>
-          <p:nvPr/>
-        </p:nvSpPr>
-        <p:spPr>
-          <a:xfrm>
-            <a:off x="640080" y="6473952"/>
-            <a:ext cx="8229600" cy="274320"/>
-          </a:xfrm>
-          <a:prstGeom prst="rect">
-            <a:avLst/>
-          </a:prstGeom>
-          <a:noFill/>
-          <a:ln/>
-        </p:spPr>
-        <p:txBody>
-          <a:bodyPr wrap="square" lIns="0" tIns="0" rIns="0" bIns="0" rtlCol="0" anchor="ctr"/>
-          <a:lstStyle/>
-          <a:p>
-            <a:pPr indent="0" marL="0">
-              <a:buNone/>
-            </a:pPr>
-            <a:r>
-              <a:rPr lang="en-US" sz="900" dirty="0">
-                <a:solidFill>
-                  <a:srgbClr val="6B7280"/>
-                </a:solidFill>
-                <a:latin typeface="Calibri" pitchFamily="34" charset="0"/>
-                <a:ea typeface="Calibri" pitchFamily="34" charset="-122"/>
-                <a:cs typeface="Calibri" pitchFamily="34" charset="-120"/>
-              </a:rPr>
-              <a:t>NB06 §4 · Ablação por blocos — PNS 2019 · Artrite em idosos ≥60</a:t>
-            </a:r>
-            <a:endParaRPr lang="en-US" sz="900" dirty="0"/>
-          </a:p>
-        </p:txBody>
-      </p:sp>
-      <p:sp>
-        <p:nvSpPr>
-          <p:cNvPr id="16" name="Text 14"/>
-          <p:cNvSpPr/>
-          <p:nvPr/>
-        </p:nvSpPr>
-        <p:spPr>
-          <a:xfrm>
-            <a:off x="11247120" y="6473952"/>
-            <a:ext cx="365760" cy="274320"/>
-          </a:xfrm>
-          <a:prstGeom prst="rect">
-            <a:avLst/>
-          </a:prstGeom>
-          <a:noFill/>
-          <a:ln/>
-        </p:spPr>
-        <p:txBody>
-          <a:bodyPr wrap="square" lIns="0" tIns="0" rIns="0" bIns="0" rtlCol="0" anchor="ctr"/>
-          <a:lstStyle/>
-          <a:p>
-            <a:pPr algn="r" indent="0" marL="0">
-              <a:buNone/>
-            </a:pPr>
-            <a:r>
-              <a:rPr lang="en-US" sz="900" dirty="0">
-                <a:solidFill>
-                  <a:srgbClr val="6B7280"/>
-                </a:solidFill>
-                <a:latin typeface="Calibri" pitchFamily="34" charset="0"/>
-                <a:ea typeface="Calibri" pitchFamily="34" charset="-122"/>
-                <a:cs typeface="Calibri" pitchFamily="34" charset="-120"/>
-              </a:rPr>
               <a:t>10</a:t>
             </a:r>
             <a:endParaRPr lang="en-US" sz="900" dirty="0"/>
@@ -4992,6 +4736,654 @@
                 <a:ea typeface="Calibri" pitchFamily="34" charset="-122"/>
                 <a:cs typeface="Calibri" pitchFamily="34" charset="-120"/>
               </a:rPr>
+              <a:t>RESULTADO 5 · REGRAS DA ÁRVORE (COBERTURA ≥ 10%)</a:t>
+            </a:r>
+            <a:endParaRPr lang="en-US" sz="1200" dirty="0"/>
+          </a:p>
+        </p:txBody>
+      </p:sp>
+      <p:sp>
+        <p:nvSpPr>
+          <p:cNvPr id="3" name="Text 1"/>
+          <p:cNvSpPr/>
+          <p:nvPr/>
+        </p:nvSpPr>
+        <p:spPr>
+          <a:xfrm>
+            <a:off x="640080" y="777240"/>
+            <a:ext cx="11155680" cy="868680"/>
+          </a:xfrm>
+          <a:prstGeom prst="rect">
+            <a:avLst/>
+          </a:prstGeom>
+          <a:noFill/>
+          <a:ln/>
+        </p:spPr>
+        <p:txBody>
+          <a:bodyPr wrap="square" lIns="0" tIns="0" rIns="0" bIns="0" rtlCol="0" anchor="ctr"/>
+          <a:lstStyle/>
+          <a:p>
+            <a:pPr indent="0" marL="0">
+              <a:buNone/>
+            </a:pPr>
+            <a:r>
+              <a:rPr lang="en-US" sz="3000" b="1" dirty="0">
+                <a:solidFill>
+                  <a:srgbClr val="1E2761"/>
+                </a:solidFill>
+                <a:latin typeface="Georgia" pitchFamily="34" charset="0"/>
+                <a:ea typeface="Georgia" pitchFamily="34" charset="-122"/>
+                <a:cs typeface="Georgia" pitchFamily="34" charset="-120"/>
+              </a:rPr>
+              <a:t>As regras descrevem perfil, não dieta</a:t>
+            </a:r>
+            <a:endParaRPr lang="en-US" sz="3000" dirty="0"/>
+          </a:p>
+        </p:txBody>
+      </p:sp>
+      <p:sp>
+        <p:nvSpPr>
+          <p:cNvPr id="4" name="Shape 2"/>
+          <p:cNvSpPr/>
+          <p:nvPr/>
+        </p:nvSpPr>
+        <p:spPr>
+          <a:xfrm>
+            <a:off x="640080" y="1783080"/>
+            <a:ext cx="10881360" cy="1463040"/>
+          </a:xfrm>
+          <a:prstGeom prst="rect">
+            <a:avLst/>
+          </a:prstGeom>
+          <a:solidFill>
+            <a:srgbClr val="F4F6FB"/>
+          </a:solidFill>
+          <a:ln w="12700">
+            <a:solidFill>
+              <a:srgbClr val="E3E8F5"/>
+            </a:solidFill>
+            <a:prstDash val="solid"/>
+          </a:ln>
+          <a:effectLst>
+            <a:outerShdw sx="100000" sy="100000" kx="0" ky="0" algn="bl" rotWithShape="0" blurRad="88900" dist="38100" dir="8100000">
+              <a:srgbClr val="000000">
+                <a:alpha val="16000"/>
+              </a:srgbClr>
+            </a:outerShdw>
+          </a:effectLst>
+        </p:spPr>
+      </p:sp>
+      <p:sp>
+        <p:nvSpPr>
+          <p:cNvPr id="5" name="Shape 3"/>
+          <p:cNvSpPr/>
+          <p:nvPr/>
+        </p:nvSpPr>
+        <p:spPr>
+          <a:xfrm>
+            <a:off x="640080" y="1783080"/>
+            <a:ext cx="82296" cy="1463040"/>
+          </a:xfrm>
+          <a:prstGeom prst="rect">
+            <a:avLst/>
+          </a:prstGeom>
+          <a:solidFill>
+            <a:srgbClr val="27AE60"/>
+          </a:solidFill>
+          <a:ln/>
+        </p:spPr>
+      </p:sp>
+      <p:sp>
+        <p:nvSpPr>
+          <p:cNvPr id="6" name="Text 4"/>
+          <p:cNvSpPr/>
+          <p:nvPr/>
+        </p:nvSpPr>
+        <p:spPr>
+          <a:xfrm>
+            <a:off x="914400" y="1920240"/>
+            <a:ext cx="10058400" cy="365760"/>
+          </a:xfrm>
+          <a:prstGeom prst="rect">
+            <a:avLst/>
+          </a:prstGeom>
+          <a:noFill/>
+          <a:ln/>
+        </p:spPr>
+        <p:txBody>
+          <a:bodyPr wrap="square" lIns="0" tIns="0" rIns="0" bIns="0" rtlCol="0" anchor="ctr"/>
+          <a:lstStyle/>
+          <a:p>
+            <a:pPr indent="0" marL="0">
+              <a:buNone/>
+            </a:pPr>
+            <a:r>
+              <a:rPr lang="en-US" sz="1450" b="1" dirty="0">
+                <a:solidFill>
+                  <a:srgbClr val="27AE60"/>
+                </a:solidFill>
+                <a:latin typeface="Georgia" pitchFamily="34" charset="0"/>
+                <a:ea typeface="Georgia" pitchFamily="34" charset="-122"/>
+                <a:cs typeface="Georgia" pitchFamily="34" charset="-120"/>
+              </a:rPr>
+              <a:t>Desenho 1 — perfil SAUDÁVEL (pureza ≈ 0,95)</a:t>
+            </a:r>
+            <a:endParaRPr lang="en-US" sz="1450" dirty="0"/>
+          </a:p>
+        </p:txBody>
+      </p:sp>
+      <p:sp>
+        <p:nvSpPr>
+          <p:cNvPr id="7" name="Text 5"/>
+          <p:cNvSpPr/>
+          <p:nvPr/>
+        </p:nvSpPr>
+        <p:spPr>
+          <a:xfrm>
+            <a:off x="914400" y="2377440"/>
+            <a:ext cx="10058400" cy="731520"/>
+          </a:xfrm>
+          <a:prstGeom prst="rect">
+            <a:avLst/>
+          </a:prstGeom>
+          <a:noFill/>
+          <a:ln/>
+        </p:spPr>
+        <p:txBody>
+          <a:bodyPr wrap="square" lIns="0" tIns="0" rIns="0" bIns="0" rtlCol="0" anchor="ctr"/>
+          <a:lstStyle/>
+          <a:p>
+            <a:pPr indent="0" marL="0">
+              <a:lnSpc>
+                <a:spcPct val="110000"/>
+              </a:lnSpc>
+              <a:buNone/>
+            </a:pPr>
+            <a:r>
+              <a:rPr lang="en-US" sz="1350" b="1" dirty="0">
+                <a:solidFill>
+                  <a:srgbClr val="6B7280"/>
+                </a:solidFill>
+                <a:latin typeface="Calibri" pitchFamily="34" charset="0"/>
+                <a:ea typeface="Calibri" pitchFamily="34" charset="-122"/>
+                <a:cs typeface="Calibri" pitchFamily="34" charset="-120"/>
+              </a:rPr>
+              <a:t>SE  </a:t>
+            </a:r>
+            <a:pPr indent="0" marL="0">
+              <a:lnSpc>
+                <a:spcPct val="110000"/>
+              </a:lnSpc>
+              <a:buNone/>
+            </a:pPr>
+            <a:r>
+              <a:rPr lang="en-US" sz="1350" dirty="0">
+                <a:solidFill>
+                  <a:srgbClr val="2B2B2B"/>
+                </a:solidFill>
+                <a:latin typeface="Calibri" pitchFamily="34" charset="0"/>
+                <a:ea typeface="Calibri" pitchFamily="34" charset="-122"/>
+                <a:cs typeface="Calibri" pitchFamily="34" charset="-120"/>
+              </a:rPr>
+              <a:t>homem  E  come feijão (≥ faixa)  E  mais escolaridade</a:t>
+            </a:r>
+            <a:pPr indent="0" marL="0">
+              <a:lnSpc>
+                <a:spcPct val="110000"/>
+              </a:lnSpc>
+              <a:buNone/>
+            </a:pPr>
+            <a:r>
+              <a:rPr lang="en-US" sz="1350" b="1" dirty="0">
+                <a:solidFill>
+                  <a:srgbClr val="27AE60"/>
+                </a:solidFill>
+                <a:latin typeface="Calibri" pitchFamily="34" charset="0"/>
+                <a:ea typeface="Calibri" pitchFamily="34" charset="-122"/>
+                <a:cs typeface="Calibri" pitchFamily="34" charset="-120"/>
+              </a:rPr>
+              <a:t>   → Saudável   (cobre 12%).</a:t>
+            </a:r>
+            <a:endParaRPr lang="en-US" sz="1350" dirty="0"/>
+          </a:p>
+        </p:txBody>
+      </p:sp>
+      <p:sp>
+        <p:nvSpPr>
+          <p:cNvPr id="8" name="Shape 6"/>
+          <p:cNvSpPr/>
+          <p:nvPr/>
+        </p:nvSpPr>
+        <p:spPr>
+          <a:xfrm>
+            <a:off x="640080" y="3429000"/>
+            <a:ext cx="10881360" cy="1920240"/>
+          </a:xfrm>
+          <a:prstGeom prst="rect">
+            <a:avLst/>
+          </a:prstGeom>
+          <a:solidFill>
+            <a:srgbClr val="F4F6FB"/>
+          </a:solidFill>
+          <a:ln w="12700">
+            <a:solidFill>
+              <a:srgbClr val="E3E8F5"/>
+            </a:solidFill>
+            <a:prstDash val="solid"/>
+          </a:ln>
+          <a:effectLst>
+            <a:outerShdw sx="100000" sy="100000" kx="0" ky="0" algn="bl" rotWithShape="0" blurRad="88900" dist="38100" dir="8100000">
+              <a:srgbClr val="000000">
+                <a:alpha val="16000"/>
+              </a:srgbClr>
+            </a:outerShdw>
+          </a:effectLst>
+        </p:spPr>
+      </p:sp>
+      <p:sp>
+        <p:nvSpPr>
+          <p:cNvPr id="9" name="Shape 7"/>
+          <p:cNvSpPr/>
+          <p:nvPr/>
+        </p:nvSpPr>
+        <p:spPr>
+          <a:xfrm>
+            <a:off x="640080" y="3429000"/>
+            <a:ext cx="82296" cy="1920240"/>
+          </a:xfrm>
+          <a:prstGeom prst="rect">
+            <a:avLst/>
+          </a:prstGeom>
+          <a:solidFill>
+            <a:srgbClr val="C0392B"/>
+          </a:solidFill>
+          <a:ln/>
+        </p:spPr>
+      </p:sp>
+      <p:sp>
+        <p:nvSpPr>
+          <p:cNvPr id="10" name="Text 8"/>
+          <p:cNvSpPr/>
+          <p:nvPr/>
+        </p:nvSpPr>
+        <p:spPr>
+          <a:xfrm>
+            <a:off x="914400" y="3566160"/>
+            <a:ext cx="10058400" cy="365760"/>
+          </a:xfrm>
+          <a:prstGeom prst="rect">
+            <a:avLst/>
+          </a:prstGeom>
+          <a:noFill/>
+          <a:ln/>
+        </p:spPr>
+        <p:txBody>
+          <a:bodyPr wrap="square" lIns="0" tIns="0" rIns="0" bIns="0" rtlCol="0" anchor="ctr"/>
+          <a:lstStyle/>
+          <a:p>
+            <a:pPr indent="0" marL="0">
+              <a:buNone/>
+            </a:pPr>
+            <a:r>
+              <a:rPr lang="en-US" sz="1450" b="1" dirty="0">
+                <a:solidFill>
+                  <a:srgbClr val="C0392B"/>
+                </a:solidFill>
+                <a:latin typeface="Georgia" pitchFamily="34" charset="0"/>
+                <a:ea typeface="Georgia" pitchFamily="34" charset="-122"/>
+                <a:cs typeface="Georgia" pitchFamily="34" charset="-120"/>
+              </a:rPr>
+              <a:t>Desenho 2 — perfil ARTRITE</a:t>
+            </a:r>
+            <a:endParaRPr lang="en-US" sz="1450" dirty="0"/>
+          </a:p>
+        </p:txBody>
+      </p:sp>
+      <p:sp>
+        <p:nvSpPr>
+          <p:cNvPr id="11" name="Text 9"/>
+          <p:cNvSpPr/>
+          <p:nvPr/>
+        </p:nvSpPr>
+        <p:spPr>
+          <a:xfrm>
+            <a:off x="914400" y="3977640"/>
+            <a:ext cx="10058400" cy="640080"/>
+          </a:xfrm>
+          <a:prstGeom prst="rect">
+            <a:avLst/>
+          </a:prstGeom>
+          <a:noFill/>
+          <a:ln/>
+        </p:spPr>
+        <p:txBody>
+          <a:bodyPr wrap="square" lIns="0" tIns="0" rIns="0" bIns="0" rtlCol="0" anchor="ctr"/>
+          <a:lstStyle/>
+          <a:p>
+            <a:pPr indent="0" marL="0">
+              <a:lnSpc>
+                <a:spcPct val="110000"/>
+              </a:lnSpc>
+              <a:buNone/>
+            </a:pPr>
+            <a:r>
+              <a:rPr lang="en-US" sz="1350" b="1" dirty="0">
+                <a:solidFill>
+                  <a:srgbClr val="6B7280"/>
+                </a:solidFill>
+                <a:latin typeface="Calibri" pitchFamily="34" charset="0"/>
+                <a:ea typeface="Calibri" pitchFamily="34" charset="-122"/>
+                <a:cs typeface="Calibri" pitchFamily="34" charset="-120"/>
+              </a:rPr>
+              <a:t>SE  </a:t>
+            </a:r>
+            <a:pPr indent="0" marL="0">
+              <a:lnSpc>
+                <a:spcPct val="110000"/>
+              </a:lnSpc>
+              <a:buNone/>
+            </a:pPr>
+            <a:r>
+              <a:rPr lang="en-US" sz="1350" dirty="0">
+                <a:solidFill>
+                  <a:srgbClr val="2B2B2B"/>
+                </a:solidFill>
+                <a:latin typeface="Calibri" pitchFamily="34" charset="0"/>
+                <a:ea typeface="Calibri" pitchFamily="34" charset="-122"/>
+                <a:cs typeface="Calibri" pitchFamily="34" charset="-120"/>
+              </a:rPr>
+              <a:t>mulher  E  60–69 anos  E  menor escolaridade  E  IRNI &gt; −4,5</a:t>
+            </a:r>
+            <a:pPr indent="0" marL="0">
+              <a:lnSpc>
+                <a:spcPct val="110000"/>
+              </a:lnSpc>
+              <a:buNone/>
+            </a:pPr>
+            <a:r>
+              <a:rPr lang="en-US" sz="1350" b="1" dirty="0">
+                <a:solidFill>
+                  <a:srgbClr val="C0392B"/>
+                </a:solidFill>
+                <a:latin typeface="Calibri" pitchFamily="34" charset="0"/>
+                <a:ea typeface="Calibri" pitchFamily="34" charset="-122"/>
+                <a:cs typeface="Calibri" pitchFamily="34" charset="-120"/>
+              </a:rPr>
+              <a:t>   → Artrite   (cobre 20%, pureza 0,56).</a:t>
+            </a:r>
+            <a:endParaRPr lang="en-US" sz="1350" dirty="0"/>
+          </a:p>
+        </p:txBody>
+      </p:sp>
+      <p:sp>
+        <p:nvSpPr>
+          <p:cNvPr id="12" name="Text 10"/>
+          <p:cNvSpPr/>
+          <p:nvPr/>
+        </p:nvSpPr>
+        <p:spPr>
+          <a:xfrm>
+            <a:off x="914400" y="4572000"/>
+            <a:ext cx="10058400" cy="640080"/>
+          </a:xfrm>
+          <a:prstGeom prst="rect">
+            <a:avLst/>
+          </a:prstGeom>
+          <a:noFill/>
+          <a:ln/>
+        </p:spPr>
+        <p:txBody>
+          <a:bodyPr wrap="square" lIns="0" tIns="0" rIns="0" bIns="0" rtlCol="0" anchor="ctr"/>
+          <a:lstStyle/>
+          <a:p>
+            <a:pPr indent="0" marL="0">
+              <a:lnSpc>
+                <a:spcPct val="110000"/>
+              </a:lnSpc>
+              <a:buNone/>
+            </a:pPr>
+            <a:r>
+              <a:rPr lang="en-US" sz="1200" i="1" dirty="0">
+                <a:solidFill>
+                  <a:srgbClr val="2B2B2B"/>
+                </a:solidFill>
+                <a:latin typeface="Calibri" pitchFamily="34" charset="0"/>
+                <a:ea typeface="Calibri" pitchFamily="34" charset="-122"/>
+                <a:cs typeface="Calibri" pitchFamily="34" charset="-120"/>
+              </a:rPr>
+              <a:t>As variáveis nutricionais (feijão, sal, tipo de leite, IRNI) entram como ramos secundários — nunca como o eixo da regra. O eixo é sexo + idade + escolaridade.</a:t>
+            </a:r>
+            <a:endParaRPr lang="en-US" sz="1200" dirty="0"/>
+          </a:p>
+        </p:txBody>
+      </p:sp>
+      <p:sp>
+        <p:nvSpPr>
+          <p:cNvPr id="13" name="Shape 11"/>
+          <p:cNvSpPr/>
+          <p:nvPr/>
+        </p:nvSpPr>
+        <p:spPr>
+          <a:xfrm>
+            <a:off x="640080" y="5532120"/>
+            <a:ext cx="10881360" cy="713232"/>
+          </a:xfrm>
+          <a:prstGeom prst="rect">
+            <a:avLst/>
+          </a:prstGeom>
+          <a:solidFill>
+            <a:srgbClr val="EEF6F0"/>
+          </a:solidFill>
+          <a:ln w="12700">
+            <a:solidFill>
+              <a:srgbClr val="1E2761"/>
+            </a:solidFill>
+            <a:prstDash val="solid"/>
+          </a:ln>
+        </p:spPr>
+      </p:sp>
+      <p:sp>
+        <p:nvSpPr>
+          <p:cNvPr id="14" name="Text 12"/>
+          <p:cNvSpPr/>
+          <p:nvPr/>
+        </p:nvSpPr>
+        <p:spPr>
+          <a:xfrm>
+            <a:off x="868680" y="5568696"/>
+            <a:ext cx="10424160" cy="640080"/>
+          </a:xfrm>
+          <a:prstGeom prst="rect">
+            <a:avLst/>
+          </a:prstGeom>
+          <a:noFill/>
+          <a:ln/>
+        </p:spPr>
+        <p:txBody>
+          <a:bodyPr wrap="square" lIns="0" tIns="0" rIns="0" bIns="0" rtlCol="0" anchor="ctr"/>
+          <a:lstStyle/>
+          <a:p>
+            <a:pPr indent="0" marL="0">
+              <a:lnSpc>
+                <a:spcPct val="106000"/>
+              </a:lnSpc>
+              <a:buNone/>
+            </a:pPr>
+            <a:r>
+              <a:rPr lang="en-US" sz="1300" b="1" dirty="0">
+                <a:solidFill>
+                  <a:srgbClr val="1E2761"/>
+                </a:solidFill>
+                <a:latin typeface="Calibri" pitchFamily="34" charset="0"/>
+                <a:ea typeface="Calibri" pitchFamily="34" charset="-122"/>
+                <a:cs typeface="Calibri" pitchFamily="34" charset="-120"/>
+              </a:rPr>
+              <a:t>O que isso significa:  </a:t>
+            </a:r>
+            <a:pPr indent="0" marL="0">
+              <a:lnSpc>
+                <a:spcPct val="106000"/>
+              </a:lnSpc>
+              <a:buNone/>
+            </a:pPr>
+            <a:r>
+              <a:rPr lang="en-US" sz="1300" dirty="0">
+                <a:solidFill>
+                  <a:srgbClr val="2B2B2B"/>
+                </a:solidFill>
+                <a:latin typeface="Calibri" pitchFamily="34" charset="0"/>
+                <a:ea typeface="Calibri" pitchFamily="34" charset="-122"/>
+                <a:cs typeface="Calibri" pitchFamily="34" charset="-120"/>
+              </a:rPr>
+              <a:t>mesmo no modelo de regras (a entrega descritiva do estilo LICAP), a dieta é coadjuvante: as folhas de maior cobertura são definidas por características da pessoa.</a:t>
+            </a:r>
+            <a:endParaRPr lang="en-US" sz="1300" dirty="0"/>
+          </a:p>
+        </p:txBody>
+      </p:sp>
+      <p:sp>
+        <p:nvSpPr>
+          <p:cNvPr id="15" name="Text 13"/>
+          <p:cNvSpPr/>
+          <p:nvPr/>
+        </p:nvSpPr>
+        <p:spPr>
+          <a:xfrm>
+            <a:off x="640080" y="6473952"/>
+            <a:ext cx="8229600" cy="274320"/>
+          </a:xfrm>
+          <a:prstGeom prst="rect">
+            <a:avLst/>
+          </a:prstGeom>
+          <a:noFill/>
+          <a:ln/>
+        </p:spPr>
+        <p:txBody>
+          <a:bodyPr wrap="square" lIns="0" tIns="0" rIns="0" bIns="0" rtlCol="0" anchor="ctr"/>
+          <a:lstStyle/>
+          <a:p>
+            <a:pPr indent="0" marL="0">
+              <a:buNone/>
+            </a:pPr>
+            <a:r>
+              <a:rPr lang="en-US" sz="900" dirty="0">
+                <a:solidFill>
+                  <a:srgbClr val="6B7280"/>
+                </a:solidFill>
+                <a:latin typeface="Calibri" pitchFamily="34" charset="0"/>
+                <a:ea typeface="Calibri" pitchFamily="34" charset="-122"/>
+                <a:cs typeface="Calibri" pitchFamily="34" charset="-120"/>
+              </a:rPr>
+              <a:t>NB06 §4 · Ablação por blocos — PNS 2019 · Artrite em idosos ≥60</a:t>
+            </a:r>
+            <a:endParaRPr lang="en-US" sz="900" dirty="0"/>
+          </a:p>
+        </p:txBody>
+      </p:sp>
+      <p:sp>
+        <p:nvSpPr>
+          <p:cNvPr id="16" name="Text 14"/>
+          <p:cNvSpPr/>
+          <p:nvPr/>
+        </p:nvSpPr>
+        <p:spPr>
+          <a:xfrm>
+            <a:off x="11247120" y="6473952"/>
+            <a:ext cx="365760" cy="274320"/>
+          </a:xfrm>
+          <a:prstGeom prst="rect">
+            <a:avLst/>
+          </a:prstGeom>
+          <a:noFill/>
+          <a:ln/>
+        </p:spPr>
+        <p:txBody>
+          <a:bodyPr wrap="square" lIns="0" tIns="0" rIns="0" bIns="0" rtlCol="0" anchor="ctr"/>
+          <a:lstStyle/>
+          <a:p>
+            <a:pPr algn="r" indent="0" marL="0">
+              <a:buNone/>
+            </a:pPr>
+            <a:r>
+              <a:rPr lang="en-US" sz="900" dirty="0">
+                <a:solidFill>
+                  <a:srgbClr val="6B7280"/>
+                </a:solidFill>
+                <a:latin typeface="Calibri" pitchFamily="34" charset="0"/>
+                <a:ea typeface="Calibri" pitchFamily="34" charset="-122"/>
+                <a:cs typeface="Calibri" pitchFamily="34" charset="-120"/>
+              </a:rPr>
+              <a:t>11</a:t>
+            </a:r>
+            <a:endParaRPr lang="en-US" sz="900" dirty="0"/>
+          </a:p>
+        </p:txBody>
+      </p:sp>
+    </p:spTree>
+  </p:cSld>
+  <p:clrMapOvr>
+    <a:masterClrMapping/>
+  </p:clrMapOvr>
+</p:sld>
+</file>
+
+<file path=ppt/slides/slide13.xml><?xml version="1.0" encoding="utf-8"?>
+<p:sld xmlns:a="http://schemas.openxmlformats.org/drawingml/2006/main" xmlns:r="http://schemas.openxmlformats.org/officeDocument/2006/relationships" xmlns:p="http://schemas.openxmlformats.org/presentationml/2006/main">
+  <p:cSld name="Slide 13">
+    <p:bg>
+      <p:bgPr>
+        <a:solidFill>
+          <a:srgbClr val="FFFFFF"/>
+        </a:solidFill>
+      </p:bgPr>
+    </p:bg>
+    <p:spTree>
+      <p:nvGrpSpPr>
+        <p:cNvPr id="1" name=""/>
+        <p:cNvGrpSpPr/>
+        <p:nvPr/>
+      </p:nvGrpSpPr>
+      <p:grpSpPr>
+        <a:xfrm>
+          <a:off x="0" y="0"/>
+          <a:ext cx="0" cy="0"/>
+          <a:chOff x="0" y="0"/>
+          <a:chExt cx="0" cy="0"/>
+        </a:xfrm>
+      </p:grpSpPr>
+      <p:sp>
+        <p:nvSpPr>
+          <p:cNvPr id="2" name="Text 0"/>
+          <p:cNvSpPr/>
+          <p:nvPr/>
+        </p:nvSpPr>
+        <p:spPr>
+          <a:xfrm>
+            <a:off x="640080" y="457200"/>
+            <a:ext cx="10972800" cy="292608"/>
+          </a:xfrm>
+          <a:prstGeom prst="rect">
+            <a:avLst/>
+          </a:prstGeom>
+          <a:noFill/>
+          <a:ln/>
+        </p:spPr>
+        <p:txBody>
+          <a:bodyPr wrap="square" lIns="0" tIns="0" rIns="0" bIns="0" rtlCol="0" anchor="ctr"/>
+          <a:lstStyle/>
+          <a:p>
+            <a:pPr indent="0" marL="0">
+              <a:buNone/>
+            </a:pPr>
+            <a:r>
+              <a:rPr lang="en-US" sz="1200" b="1" spc="300" kern="0" dirty="0">
+                <a:solidFill>
+                  <a:srgbClr val="E8A33D"/>
+                </a:solidFill>
+                <a:latin typeface="Calibri" pitchFamily="34" charset="0"/>
+                <a:ea typeface="Calibri" pitchFamily="34" charset="-122"/>
+                <a:cs typeface="Calibri" pitchFamily="34" charset="-120"/>
+              </a:rPr>
               <a:t>COMPARAÇÃO DE MODELOS · CONJUNTO-RESPOSTA M2</a:t>
             </a:r>
             <a:endParaRPr lang="en-US" sz="1200" dirty="0"/>
@@ -5039,7 +5431,7 @@
       </p:sp>
       <p:graphicFrame>
         <p:nvGraphicFramePr>
-          <p:cNvPr id="13" name="Table 0"/>
+          <p:cNvPr id="14" name="Table 0"/>
           <p:cNvGraphicFramePr>
             <a:graphicFrameLocks noGrp="1"/>
           </p:cNvGraphicFramePr>
@@ -6387,309 +6779,6 @@
                 <a:ea typeface="Calibri" pitchFamily="34" charset="-122"/>
                 <a:cs typeface="Calibri" pitchFamily="34" charset="-120"/>
               </a:rPr>
-              <a:t>11</a:t>
-            </a:r>
-            <a:endParaRPr lang="en-US" sz="900" dirty="0"/>
-          </a:p>
-        </p:txBody>
-      </p:sp>
-    </p:spTree>
-  </p:cSld>
-  <p:clrMapOvr>
-    <a:masterClrMapping/>
-  </p:clrMapOvr>
-</p:sld>
-</file>
-
-<file path=ppt/slides/slide13.xml><?xml version="1.0" encoding="utf-8"?>
-<p:sld xmlns:a="http://schemas.openxmlformats.org/drawingml/2006/main" xmlns:r="http://schemas.openxmlformats.org/officeDocument/2006/relationships" xmlns:p="http://schemas.openxmlformats.org/presentationml/2006/main">
-  <p:cSld name="Slide 13">
-    <p:bg>
-      <p:bgPr>
-        <a:solidFill>
-          <a:srgbClr val="FFFFFF"/>
-        </a:solidFill>
-      </p:bgPr>
-    </p:bg>
-    <p:spTree>
-      <p:nvGrpSpPr>
-        <p:cNvPr id="1" name=""/>
-        <p:cNvGrpSpPr/>
-        <p:nvPr/>
-      </p:nvGrpSpPr>
-      <p:grpSpPr>
-        <a:xfrm>
-          <a:off x="0" y="0"/>
-          <a:ext cx="0" cy="0"/>
-          <a:chOff x="0" y="0"/>
-          <a:chExt cx="0" cy="0"/>
-        </a:xfrm>
-      </p:grpSpPr>
-      <p:sp>
-        <p:nvSpPr>
-          <p:cNvPr id="2" name="Text 0"/>
-          <p:cNvSpPr/>
-          <p:nvPr/>
-        </p:nvSpPr>
-        <p:spPr>
-          <a:xfrm>
-            <a:off x="640080" y="457200"/>
-            <a:ext cx="10972800" cy="292608"/>
-          </a:xfrm>
-          <a:prstGeom prst="rect">
-            <a:avLst/>
-          </a:prstGeom>
-          <a:noFill/>
-          <a:ln/>
-        </p:spPr>
-        <p:txBody>
-          <a:bodyPr wrap="square" lIns="0" tIns="0" rIns="0" bIns="0" rtlCol="0" anchor="ctr"/>
-          <a:lstStyle/>
-          <a:p>
-            <a:pPr indent="0" marL="0">
-              <a:buNone/>
-            </a:pPr>
-            <a:r>
-              <a:rPr lang="en-US" sz="1200" b="1" spc="300" kern="0" dirty="0">
-                <a:solidFill>
-                  <a:srgbClr val="E8A33D"/>
-                </a:solidFill>
-                <a:latin typeface="Calibri" pitchFamily="34" charset="0"/>
-                <a:ea typeface="Calibri" pitchFamily="34" charset="-122"/>
-                <a:cs typeface="Calibri" pitchFamily="34" charset="-120"/>
-              </a:rPr>
-              <a:t>CHECAGEM INDEPENDENTE · ENTROPIA (NB06 §3)</a:t>
-            </a:r>
-            <a:endParaRPr lang="en-US" sz="1200" dirty="0"/>
-          </a:p>
-        </p:txBody>
-      </p:sp>
-      <p:sp>
-        <p:nvSpPr>
-          <p:cNvPr id="3" name="Text 1"/>
-          <p:cNvSpPr/>
-          <p:nvPr/>
-        </p:nvSpPr>
-        <p:spPr>
-          <a:xfrm>
-            <a:off x="640080" y="777240"/>
-            <a:ext cx="11155680" cy="868680"/>
-          </a:xfrm>
-          <a:prstGeom prst="rect">
-            <a:avLst/>
-          </a:prstGeom>
-          <a:noFill/>
-          <a:ln/>
-        </p:spPr>
-        <p:txBody>
-          <a:bodyPr wrap="square" lIns="0" tIns="0" rIns="0" bIns="0" rtlCol="0" anchor="ctr"/>
-          <a:lstStyle/>
-          <a:p>
-            <a:pPr indent="0" marL="0">
-              <a:buNone/>
-            </a:pPr>
-            <a:r>
-              <a:rPr lang="en-US" sz="3000" b="1" dirty="0">
-                <a:solidFill>
-                  <a:srgbClr val="1E2761"/>
-                </a:solidFill>
-                <a:latin typeface="Georgia" pitchFamily="34" charset="0"/>
-                <a:ea typeface="Georgia" pitchFamily="34" charset="-122"/>
-                <a:cs typeface="Georgia" pitchFamily="34" charset="-120"/>
-              </a:rPr>
-              <a:t>A entropia já apontava o mesmo</a:t>
-            </a:r>
-            <a:endParaRPr lang="en-US" sz="3000" dirty="0"/>
-          </a:p>
-        </p:txBody>
-      </p:sp>
-      <p:pic>
-        <p:nvPicPr>
-          <p:cNvPr id="4" name="Image 0" descr="figuras/entropia_ranking_su.png">    </p:cNvPr>
-          <p:cNvPicPr>
-            <a:picLocks noChangeAspect="1"/>
-          </p:cNvPicPr>
-          <p:nvPr/>
-        </p:nvPicPr>
-        <p:blipFill>
-          <a:blip r:embed="rId1"/>
-          <a:stretch>
-            <a:fillRect/>
-          </a:stretch>
-        </p:blipFill>
-        <p:spPr>
-          <a:xfrm>
-            <a:off x="2455575" y="1783080"/>
-            <a:ext cx="7250369" cy="3383280"/>
-          </a:xfrm>
-          <a:prstGeom prst="rect">
-            <a:avLst/>
-          </a:prstGeom>
-          <a:effectLst>
-            <a:outerShdw sx="100000" sy="100000" kx="0" ky="0" algn="bl" rotWithShape="0" blurRad="88900" dist="38100" dir="8100000">
-              <a:srgbClr val="000000">
-                <a:alpha val="16000"/>
-              </a:srgbClr>
-            </a:outerShdw>
-          </a:effectLst>
-        </p:spPr>
-      </p:pic>
-      <p:sp>
-        <p:nvSpPr>
-          <p:cNvPr id="5" name="Shape 2"/>
-          <p:cNvSpPr/>
-          <p:nvPr/>
-        </p:nvSpPr>
-        <p:spPr>
-          <a:xfrm>
-            <a:off x="640080" y="5486400"/>
-            <a:ext cx="10881360" cy="713232"/>
-          </a:xfrm>
-          <a:prstGeom prst="rect">
-            <a:avLst/>
-          </a:prstGeom>
-          <a:solidFill>
-            <a:srgbClr val="EEF6F0"/>
-          </a:solidFill>
-          <a:ln w="12700">
-            <a:solidFill>
-              <a:srgbClr val="2980B9"/>
-            </a:solidFill>
-            <a:prstDash val="solid"/>
-          </a:ln>
-        </p:spPr>
-      </p:sp>
-      <p:sp>
-        <p:nvSpPr>
-          <p:cNvPr id="6" name="Text 3"/>
-          <p:cNvSpPr/>
-          <p:nvPr/>
-        </p:nvSpPr>
-        <p:spPr>
-          <a:xfrm>
-            <a:off x="868680" y="5522976"/>
-            <a:ext cx="10424160" cy="640080"/>
-          </a:xfrm>
-          <a:prstGeom prst="rect">
-            <a:avLst/>
-          </a:prstGeom>
-          <a:noFill/>
-          <a:ln/>
-        </p:spPr>
-        <p:txBody>
-          <a:bodyPr wrap="square" lIns="0" tIns="0" rIns="0" bIns="0" rtlCol="0" anchor="ctr"/>
-          <a:lstStyle/>
-          <a:p>
-            <a:pPr indent="0" marL="0">
-              <a:lnSpc>
-                <a:spcPct val="106000"/>
-              </a:lnSpc>
-              <a:buNone/>
-            </a:pPr>
-            <a:r>
-              <a:rPr lang="en-US" sz="1300" b="1" dirty="0">
-                <a:solidFill>
-                  <a:srgbClr val="2980B9"/>
-                </a:solidFill>
-                <a:latin typeface="Calibri" pitchFamily="34" charset="0"/>
-                <a:ea typeface="Calibri" pitchFamily="34" charset="-122"/>
-                <a:cs typeface="Calibri" pitchFamily="34" charset="-120"/>
-              </a:rPr>
-              <a:t>Triangulação:  </a:t>
-            </a:r>
-            <a:pPr indent="0" marL="0">
-              <a:lnSpc>
-                <a:spcPct val="106000"/>
-              </a:lnSpc>
-              <a:buNone/>
-            </a:pPr>
-            <a:r>
-              <a:rPr lang="en-US" sz="1300" dirty="0">
-                <a:solidFill>
-                  <a:srgbClr val="2B2B2B"/>
-                </a:solidFill>
-                <a:latin typeface="Calibri" pitchFamily="34" charset="0"/>
-                <a:ea typeface="Calibri" pitchFamily="34" charset="-122"/>
-                <a:cs typeface="Calibri" pitchFamily="34" charset="-120"/>
-              </a:rPr>
-              <a:t>o ranking por Incerteza Simétrica (independente do classificador) coloca autoavaliação de saúde, sexo e uso de serviço no topo; a maioria dos itens alimentares fica perto de zero. Três lentes — entropia, Gini e OR — convergem.</a:t>
-            </a:r>
-            <a:endParaRPr lang="en-US" sz="1300" dirty="0"/>
-          </a:p>
-        </p:txBody>
-      </p:sp>
-      <p:sp>
-        <p:nvSpPr>
-          <p:cNvPr id="7" name="Text 4"/>
-          <p:cNvSpPr/>
-          <p:nvPr/>
-        </p:nvSpPr>
-        <p:spPr>
-          <a:xfrm>
-            <a:off x="640080" y="6473952"/>
-            <a:ext cx="8229600" cy="274320"/>
-          </a:xfrm>
-          <a:prstGeom prst="rect">
-            <a:avLst/>
-          </a:prstGeom>
-          <a:noFill/>
-          <a:ln/>
-        </p:spPr>
-        <p:txBody>
-          <a:bodyPr wrap="square" lIns="0" tIns="0" rIns="0" bIns="0" rtlCol="0" anchor="ctr"/>
-          <a:lstStyle/>
-          <a:p>
-            <a:pPr indent="0" marL="0">
-              <a:buNone/>
-            </a:pPr>
-            <a:r>
-              <a:rPr lang="en-US" sz="900" dirty="0">
-                <a:solidFill>
-                  <a:srgbClr val="6B7280"/>
-                </a:solidFill>
-                <a:latin typeface="Calibri" pitchFamily="34" charset="0"/>
-                <a:ea typeface="Calibri" pitchFamily="34" charset="-122"/>
-                <a:cs typeface="Calibri" pitchFamily="34" charset="-120"/>
-              </a:rPr>
-              <a:t>NB06 §4 · Ablação por blocos — PNS 2019 · Artrite em idosos ≥60</a:t>
-            </a:r>
-            <a:endParaRPr lang="en-US" sz="900" dirty="0"/>
-          </a:p>
-        </p:txBody>
-      </p:sp>
-      <p:sp>
-        <p:nvSpPr>
-          <p:cNvPr id="8" name="Text 5"/>
-          <p:cNvSpPr/>
-          <p:nvPr/>
-        </p:nvSpPr>
-        <p:spPr>
-          <a:xfrm>
-            <a:off x="11247120" y="6473952"/>
-            <a:ext cx="365760" cy="274320"/>
-          </a:xfrm>
-          <a:prstGeom prst="rect">
-            <a:avLst/>
-          </a:prstGeom>
-          <a:noFill/>
-          <a:ln/>
-        </p:spPr>
-        <p:txBody>
-          <a:bodyPr wrap="square" lIns="0" tIns="0" rIns="0" bIns="0" rtlCol="0" anchor="ctr"/>
-          <a:lstStyle/>
-          <a:p>
-            <a:pPr algn="r" indent="0" marL="0">
-              <a:buNone/>
-            </a:pPr>
-            <a:r>
-              <a:rPr lang="en-US" sz="900" dirty="0">
-                <a:solidFill>
-                  <a:srgbClr val="6B7280"/>
-                </a:solidFill>
-                <a:latin typeface="Calibri" pitchFamily="34" charset="0"/>
-                <a:ea typeface="Calibri" pitchFamily="34" charset="-122"/>
-                <a:cs typeface="Calibri" pitchFamily="34" charset="-120"/>
-              </a:rPr>
               <a:t>12</a:t>
             </a:r>
             <a:endParaRPr lang="en-US" sz="900" dirty="0"/>
@@ -6761,7 +6850,7 @@
                 <a:ea typeface="Calibri" pitchFamily="34" charset="-122"/>
                 <a:cs typeface="Calibri" pitchFamily="34" charset="-120"/>
               </a:rPr>
-              <a:t>DISCUSSÃO · A RESPOSTA À PERGUNTA</a:t>
+              <a:t>CHECAGEM INDEPENDENTE · ENTROPIA (NB06 §3)</a:t>
             </a:r>
             <a:endParaRPr lang="en-US" sz="1200" dirty="0"/>
           </a:p>
@@ -6800,35 +6889,34 @@
                 <a:ea typeface="Georgia" pitchFamily="34" charset="-122"/>
                 <a:cs typeface="Georgia" pitchFamily="34" charset="-120"/>
               </a:rPr>
-              <a:t>O que diferencia idoso com artrite do saudável</a:t>
+              <a:t>A entropia já apontava o mesmo</a:t>
             </a:r>
             <a:endParaRPr lang="en-US" sz="3000" dirty="0"/>
           </a:p>
         </p:txBody>
       </p:sp>
-      <p:sp>
-        <p:nvSpPr>
-          <p:cNvPr id="4" name="Shape 2"/>
-          <p:cNvSpPr/>
-          <p:nvPr/>
-        </p:nvSpPr>
-        <p:spPr>
-          <a:xfrm>
-            <a:off x="640080" y="1783080"/>
-            <a:ext cx="10881360" cy="1371600"/>
-          </a:xfrm>
-          <a:prstGeom prst="rect">
-            <a:avLst/>
-          </a:prstGeom>
-          <a:solidFill>
-            <a:srgbClr val="F4F6FB"/>
-          </a:solidFill>
-          <a:ln w="12700">
-            <a:solidFill>
-              <a:srgbClr val="E3E8F5"/>
-            </a:solidFill>
-            <a:prstDash val="solid"/>
-          </a:ln>
+      <p:pic>
+        <p:nvPicPr>
+          <p:cNvPr id="4" name="Image 0" descr="figuras/entropia_ranking_su.png">    </p:cNvPr>
+          <p:cNvPicPr>
+            <a:picLocks noChangeAspect="1"/>
+          </p:cNvPicPr>
+          <p:nvPr/>
+        </p:nvPicPr>
+        <p:blipFill>
+          <a:blip r:embed="rId1"/>
+          <a:stretch>
+            <a:fillRect/>
+          </a:stretch>
+        </p:blipFill>
+        <p:spPr>
+          <a:xfrm>
+            <a:off x="2455575" y="1783080"/>
+            <a:ext cx="7250369" cy="3383280"/>
+          </a:xfrm>
+          <a:prstGeom prst="rect">
+            <a:avLst/>
+          </a:prstGeom>
           <a:effectLst>
             <a:outerShdw sx="100000" sy="100000" kx="0" ky="0" algn="bl" rotWithShape="0" blurRad="88900" dist="38100" dir="8100000">
               <a:srgbClr val="000000">
@@ -6837,135 +6925,42 @@
             </a:outerShdw>
           </a:effectLst>
         </p:spPr>
-      </p:sp>
-      <p:sp>
-        <p:nvSpPr>
-          <p:cNvPr id="5" name="Shape 3"/>
-          <p:cNvSpPr/>
-          <p:nvPr/>
-        </p:nvSpPr>
-        <p:spPr>
-          <a:xfrm>
-            <a:off x="640080" y="1783080"/>
-            <a:ext cx="82296" cy="1371600"/>
+      </p:pic>
+      <p:sp>
+        <p:nvSpPr>
+          <p:cNvPr id="5" name="Shape 2"/>
+          <p:cNvSpPr/>
+          <p:nvPr/>
+        </p:nvSpPr>
+        <p:spPr>
+          <a:xfrm>
+            <a:off x="640080" y="5486400"/>
+            <a:ext cx="10881360" cy="713232"/>
           </a:xfrm>
           <a:prstGeom prst="rect">
             <a:avLst/>
           </a:prstGeom>
           <a:solidFill>
-            <a:srgbClr val="27AE60"/>
+            <a:srgbClr val="EEF6F0"/>
           </a:solidFill>
-          <a:ln/>
-        </p:spPr>
-      </p:sp>
-      <p:sp>
-        <p:nvSpPr>
-          <p:cNvPr id="6" name="Shape 4"/>
-          <p:cNvSpPr/>
-          <p:nvPr/>
-        </p:nvSpPr>
-        <p:spPr>
-          <a:xfrm>
-            <a:off x="868680" y="2194560"/>
-            <a:ext cx="548640" cy="548640"/>
-          </a:xfrm>
-          <a:prstGeom prst="ellipse">
-            <a:avLst/>
-          </a:prstGeom>
-          <a:solidFill>
-            <a:srgbClr val="27AE60"/>
-          </a:solidFill>
-          <a:ln/>
-        </p:spPr>
-      </p:sp>
-      <p:sp>
-        <p:nvSpPr>
-          <p:cNvPr id="7" name="Text 5"/>
-          <p:cNvSpPr/>
-          <p:nvPr/>
-        </p:nvSpPr>
-        <p:spPr>
-          <a:xfrm>
-            <a:off x="868680" y="2194560"/>
-            <a:ext cx="548640" cy="548640"/>
-          </a:xfrm>
-          <a:prstGeom prst="rect">
-            <a:avLst/>
-          </a:prstGeom>
-          <a:noFill/>
-          <a:ln/>
-        </p:spPr>
-        <p:txBody>
-          <a:bodyPr wrap="square" lIns="0" tIns="0" rIns="0" bIns="0" rtlCol="0" anchor="ctr"/>
-          <a:lstStyle/>
-          <a:p>
-            <a:pPr algn="ctr" indent="0" marL="0">
-              <a:buNone/>
-            </a:pPr>
-            <a:r>
-              <a:rPr lang="en-US" sz="2200" b="1" dirty="0">
-                <a:solidFill>
-                  <a:srgbClr val="FFFFFF"/>
-                </a:solidFill>
-                <a:latin typeface="Georgia" pitchFamily="34" charset="0"/>
-                <a:ea typeface="Georgia" pitchFamily="34" charset="-122"/>
-                <a:cs typeface="Georgia" pitchFamily="34" charset="-120"/>
-              </a:rPr>
-              <a:t>✓</a:t>
-            </a:r>
-            <a:endParaRPr lang="en-US" sz="2200" dirty="0"/>
-          </a:p>
-        </p:txBody>
-      </p:sp>
-      <p:sp>
-        <p:nvSpPr>
-          <p:cNvPr id="8" name="Text 6"/>
-          <p:cNvSpPr/>
-          <p:nvPr/>
-        </p:nvSpPr>
-        <p:spPr>
-          <a:xfrm>
-            <a:off x="1600200" y="1947672"/>
-            <a:ext cx="9692640" cy="384048"/>
-          </a:xfrm>
-          <a:prstGeom prst="rect">
-            <a:avLst/>
-          </a:prstGeom>
-          <a:noFill/>
-          <a:ln/>
-        </p:spPr>
-        <p:txBody>
-          <a:bodyPr wrap="square" lIns="0" tIns="0" rIns="0" bIns="0" rtlCol="0" anchor="ctr"/>
-          <a:lstStyle/>
-          <a:p>
-            <a:pPr indent="0" marL="0">
-              <a:buNone/>
-            </a:pPr>
-            <a:r>
-              <a:rPr lang="en-US" sz="1550" b="1" dirty="0">
-                <a:solidFill>
-                  <a:srgbClr val="27AE60"/>
-                </a:solidFill>
-                <a:latin typeface="Georgia" pitchFamily="34" charset="0"/>
-                <a:ea typeface="Georgia" pitchFamily="34" charset="-122"/>
-                <a:cs typeface="Georgia" pitchFamily="34" charset="-120"/>
-              </a:rPr>
-              <a:t>DIFERENCIAM</a:t>
-            </a:r>
-            <a:endParaRPr lang="en-US" sz="1550" dirty="0"/>
-          </a:p>
-        </p:txBody>
-      </p:sp>
-      <p:sp>
-        <p:nvSpPr>
-          <p:cNvPr id="9" name="Text 7"/>
-          <p:cNvSpPr/>
-          <p:nvPr/>
-        </p:nvSpPr>
-        <p:spPr>
-          <a:xfrm>
-            <a:off x="1600200" y="2331720"/>
-            <a:ext cx="9692640" cy="731520"/>
+          <a:ln w="12700">
+            <a:solidFill>
+              <a:srgbClr val="2980B9"/>
+            </a:solidFill>
+            <a:prstDash val="solid"/>
+          </a:ln>
+        </p:spPr>
+      </p:sp>
+      <p:sp>
+        <p:nvSpPr>
+          <p:cNvPr id="6" name="Text 3"/>
+          <p:cNvSpPr/>
+          <p:nvPr/>
+        </p:nvSpPr>
+        <p:spPr>
+          <a:xfrm>
+            <a:off x="868680" y="5522976"/>
+            <a:ext cx="10424160" cy="640080"/>
           </a:xfrm>
           <a:prstGeom prst="rect">
             <a:avLst/>
@@ -6979,12 +6974,29 @@
           <a:p>
             <a:pPr indent="0" marL="0">
               <a:lnSpc>
-                <a:spcPct val="110000"/>
+                <a:spcPct val="106000"/>
               </a:lnSpc>
               <a:buNone/>
             </a:pPr>
             <a:r>
-              <a:rPr lang="en-US" sz="1250" dirty="0">
+              <a:rPr lang="en-US" sz="1300" b="1" dirty="0">
+                <a:solidFill>
+                  <a:srgbClr val="2980B9"/>
+                </a:solidFill>
+                <a:latin typeface="Calibri" pitchFamily="34" charset="0"/>
+                <a:ea typeface="Calibri" pitchFamily="34" charset="-122"/>
+                <a:cs typeface="Calibri" pitchFamily="34" charset="-120"/>
+              </a:rPr>
+              <a:t>Triangulação:  </a:t>
+            </a:r>
+            <a:pPr indent="0" marL="0">
+              <a:lnSpc>
+                <a:spcPct val="106000"/>
+              </a:lnSpc>
+              <a:buNone/>
+            </a:pPr>
+            <a:r>
+              <a:rPr lang="en-US" sz="1300" dirty="0">
                 <a:solidFill>
                   <a:srgbClr val="2B2B2B"/>
                 </a:solidFill>
@@ -6992,399 +7004,15 @@
                 <a:ea typeface="Calibri" pitchFamily="34" charset="-122"/>
                 <a:cs typeface="Calibri" pitchFamily="34" charset="-120"/>
               </a:rPr>
-              <a:t>Sexo feminino (OR 2,5–4,7), idade mais avançada e o estado de saúde (comorbidades, limitação funcional, autoavaliação ruim).</a:t>
-            </a:r>
-            <a:endParaRPr lang="en-US" sz="1250" dirty="0"/>
-          </a:p>
-        </p:txBody>
-      </p:sp>
-      <p:sp>
-        <p:nvSpPr>
-          <p:cNvPr id="10" name="Shape 8"/>
-          <p:cNvSpPr/>
-          <p:nvPr/>
-        </p:nvSpPr>
-        <p:spPr>
-          <a:xfrm>
-            <a:off x="640080" y="3264408"/>
-            <a:ext cx="10881360" cy="1371600"/>
-          </a:xfrm>
-          <a:prstGeom prst="rect">
-            <a:avLst/>
-          </a:prstGeom>
-          <a:solidFill>
-            <a:srgbClr val="F4F6FB"/>
-          </a:solidFill>
-          <a:ln w="12700">
-            <a:solidFill>
-              <a:srgbClr val="E3E8F5"/>
-            </a:solidFill>
-            <a:prstDash val="solid"/>
-          </a:ln>
-          <a:effectLst>
-            <a:outerShdw sx="100000" sy="100000" kx="0" ky="0" algn="bl" rotWithShape="0" blurRad="88900" dist="38100" dir="8100000">
-              <a:srgbClr val="000000">
-                <a:alpha val="16000"/>
-              </a:srgbClr>
-            </a:outerShdw>
-          </a:effectLst>
-        </p:spPr>
-      </p:sp>
-      <p:sp>
-        <p:nvSpPr>
-          <p:cNvPr id="11" name="Shape 9"/>
-          <p:cNvSpPr/>
-          <p:nvPr/>
-        </p:nvSpPr>
-        <p:spPr>
-          <a:xfrm>
-            <a:off x="640080" y="3264408"/>
-            <a:ext cx="82296" cy="1371600"/>
-          </a:xfrm>
-          <a:prstGeom prst="rect">
-            <a:avLst/>
-          </a:prstGeom>
-          <a:solidFill>
-            <a:srgbClr val="C0392B"/>
-          </a:solidFill>
-          <a:ln/>
-        </p:spPr>
-      </p:sp>
-      <p:sp>
-        <p:nvSpPr>
-          <p:cNvPr id="12" name="Shape 10"/>
-          <p:cNvSpPr/>
-          <p:nvPr/>
-        </p:nvSpPr>
-        <p:spPr>
-          <a:xfrm>
-            <a:off x="868680" y="3675888"/>
-            <a:ext cx="548640" cy="548640"/>
-          </a:xfrm>
-          <a:prstGeom prst="ellipse">
-            <a:avLst/>
-          </a:prstGeom>
-          <a:solidFill>
-            <a:srgbClr val="C0392B"/>
-          </a:solidFill>
-          <a:ln/>
-        </p:spPr>
-      </p:sp>
-      <p:sp>
-        <p:nvSpPr>
-          <p:cNvPr id="13" name="Text 11"/>
-          <p:cNvSpPr/>
-          <p:nvPr/>
-        </p:nvSpPr>
-        <p:spPr>
-          <a:xfrm>
-            <a:off x="868680" y="3675888"/>
-            <a:ext cx="548640" cy="548640"/>
-          </a:xfrm>
-          <a:prstGeom prst="rect">
-            <a:avLst/>
-          </a:prstGeom>
-          <a:noFill/>
-          <a:ln/>
-        </p:spPr>
-        <p:txBody>
-          <a:bodyPr wrap="square" lIns="0" tIns="0" rIns="0" bIns="0" rtlCol="0" anchor="ctr"/>
-          <a:lstStyle/>
-          <a:p>
-            <a:pPr algn="ctr" indent="0" marL="0">
-              <a:buNone/>
-            </a:pPr>
-            <a:r>
-              <a:rPr lang="en-US" sz="2200" b="1" dirty="0">
-                <a:solidFill>
-                  <a:srgbClr val="FFFFFF"/>
-                </a:solidFill>
-                <a:latin typeface="Georgia" pitchFamily="34" charset="0"/>
-                <a:ea typeface="Georgia" pitchFamily="34" charset="-122"/>
-                <a:cs typeface="Georgia" pitchFamily="34" charset="-120"/>
-              </a:rPr>
-              <a:t>✕</a:t>
-            </a:r>
-            <a:endParaRPr lang="en-US" sz="2200" dirty="0"/>
-          </a:p>
-        </p:txBody>
-      </p:sp>
-      <p:sp>
-        <p:nvSpPr>
-          <p:cNvPr id="14" name="Text 12"/>
-          <p:cNvSpPr/>
-          <p:nvPr/>
-        </p:nvSpPr>
-        <p:spPr>
-          <a:xfrm>
-            <a:off x="1600200" y="3429000"/>
-            <a:ext cx="9692640" cy="384048"/>
-          </a:xfrm>
-          <a:prstGeom prst="rect">
-            <a:avLst/>
-          </a:prstGeom>
-          <a:noFill/>
-          <a:ln/>
-        </p:spPr>
-        <p:txBody>
-          <a:bodyPr wrap="square" lIns="0" tIns="0" rIns="0" bIns="0" rtlCol="0" anchor="ctr"/>
-          <a:lstStyle/>
-          <a:p>
-            <a:pPr indent="0" marL="0">
-              <a:buNone/>
-            </a:pPr>
-            <a:r>
-              <a:rPr lang="en-US" sz="1550" b="1" dirty="0">
-                <a:solidFill>
-                  <a:srgbClr val="C0392B"/>
-                </a:solidFill>
-                <a:latin typeface="Georgia" pitchFamily="34" charset="0"/>
-                <a:ea typeface="Georgia" pitchFamily="34" charset="-122"/>
-                <a:cs typeface="Georgia" pitchFamily="34" charset="-120"/>
-              </a:rPr>
-              <a:t>NÃO DIFERENCIAM</a:t>
-            </a:r>
-            <a:endParaRPr lang="en-US" sz="1550" dirty="0"/>
-          </a:p>
-        </p:txBody>
-      </p:sp>
-      <p:sp>
-        <p:nvSpPr>
-          <p:cNvPr id="15" name="Text 13"/>
-          <p:cNvSpPr/>
-          <p:nvPr/>
-        </p:nvSpPr>
-        <p:spPr>
-          <a:xfrm>
-            <a:off x="1600200" y="3813048"/>
-            <a:ext cx="9692640" cy="731520"/>
-          </a:xfrm>
-          <a:prstGeom prst="rect">
-            <a:avLst/>
-          </a:prstGeom>
-          <a:noFill/>
-          <a:ln/>
-        </p:spPr>
-        <p:txBody>
-          <a:bodyPr wrap="square" lIns="0" tIns="0" rIns="0" bIns="0" rtlCol="0" anchor="ctr"/>
-          <a:lstStyle/>
-          <a:p>
-            <a:pPr indent="0" marL="0">
-              <a:lnSpc>
-                <a:spcPct val="110000"/>
-              </a:lnSpc>
-              <a:buNone/>
-            </a:pPr>
-            <a:r>
-              <a:rPr lang="en-US" sz="1250" dirty="0">
-                <a:solidFill>
-                  <a:srgbClr val="2B2B2B"/>
-                </a:solidFill>
-                <a:latin typeface="Calibri" pitchFamily="34" charset="0"/>
-                <a:ea typeface="Calibri" pitchFamily="34" charset="-122"/>
-                <a:cs typeface="Calibri" pitchFamily="34" charset="-120"/>
-              </a:rPr>
-              <a:t>Os padrões nutricionais: ΔF1/ΔAUC ≈ 0 ao acrescentar a dieta; IRNI nunca significativo; itens no fim do ranking.</a:t>
-            </a:r>
-            <a:endParaRPr lang="en-US" sz="1250" dirty="0"/>
-          </a:p>
-        </p:txBody>
-      </p:sp>
-      <p:sp>
-        <p:nvSpPr>
-          <p:cNvPr id="16" name="Shape 14"/>
-          <p:cNvSpPr/>
-          <p:nvPr/>
-        </p:nvSpPr>
-        <p:spPr>
-          <a:xfrm>
-            <a:off x="640080" y="4745736"/>
-            <a:ext cx="10881360" cy="1371600"/>
-          </a:xfrm>
-          <a:prstGeom prst="rect">
-            <a:avLst/>
-          </a:prstGeom>
-          <a:solidFill>
-            <a:srgbClr val="F4F6FB"/>
-          </a:solidFill>
-          <a:ln w="12700">
-            <a:solidFill>
-              <a:srgbClr val="E3E8F5"/>
-            </a:solidFill>
-            <a:prstDash val="solid"/>
-          </a:ln>
-          <a:effectLst>
-            <a:outerShdw sx="100000" sy="100000" kx="0" ky="0" algn="bl" rotWithShape="0" blurRad="88900" dist="38100" dir="8100000">
-              <a:srgbClr val="000000">
-                <a:alpha val="16000"/>
-              </a:srgbClr>
-            </a:outerShdw>
-          </a:effectLst>
-        </p:spPr>
-      </p:sp>
-      <p:sp>
-        <p:nvSpPr>
-          <p:cNvPr id="17" name="Shape 15"/>
-          <p:cNvSpPr/>
-          <p:nvPr/>
-        </p:nvSpPr>
-        <p:spPr>
-          <a:xfrm>
-            <a:off x="640080" y="4745736"/>
-            <a:ext cx="82296" cy="1371600"/>
-          </a:xfrm>
-          <a:prstGeom prst="rect">
-            <a:avLst/>
-          </a:prstGeom>
-          <a:solidFill>
-            <a:srgbClr val="6B7280"/>
-          </a:solidFill>
-          <a:ln/>
-        </p:spPr>
-      </p:sp>
-      <p:sp>
-        <p:nvSpPr>
-          <p:cNvPr id="18" name="Shape 16"/>
-          <p:cNvSpPr/>
-          <p:nvPr/>
-        </p:nvSpPr>
-        <p:spPr>
-          <a:xfrm>
-            <a:off x="868680" y="5157216"/>
-            <a:ext cx="548640" cy="548640"/>
-          </a:xfrm>
-          <a:prstGeom prst="ellipse">
-            <a:avLst/>
-          </a:prstGeom>
-          <a:solidFill>
-            <a:srgbClr val="6B7280"/>
-          </a:solidFill>
-          <a:ln/>
-        </p:spPr>
-      </p:sp>
-      <p:sp>
-        <p:nvSpPr>
-          <p:cNvPr id="19" name="Text 17"/>
-          <p:cNvSpPr/>
-          <p:nvPr/>
-        </p:nvSpPr>
-        <p:spPr>
-          <a:xfrm>
-            <a:off x="868680" y="5157216"/>
-            <a:ext cx="548640" cy="548640"/>
-          </a:xfrm>
-          <a:prstGeom prst="rect">
-            <a:avLst/>
-          </a:prstGeom>
-          <a:noFill/>
-          <a:ln/>
-        </p:spPr>
-        <p:txBody>
-          <a:bodyPr wrap="square" lIns="0" tIns="0" rIns="0" bIns="0" rtlCol="0" anchor="ctr"/>
-          <a:lstStyle/>
-          <a:p>
-            <a:pPr algn="ctr" indent="0" marL="0">
-              <a:buNone/>
-            </a:pPr>
-            <a:r>
-              <a:rPr lang="en-US" sz="2200" b="1" dirty="0">
-                <a:solidFill>
-                  <a:srgbClr val="FFFFFF"/>
-                </a:solidFill>
-                <a:latin typeface="Georgia" pitchFamily="34" charset="0"/>
-                <a:ea typeface="Georgia" pitchFamily="34" charset="-122"/>
-                <a:cs typeface="Georgia" pitchFamily="34" charset="-120"/>
-              </a:rPr>
-              <a:t>⟲</a:t>
-            </a:r>
-            <a:endParaRPr lang="en-US" sz="2200" dirty="0"/>
-          </a:p>
-        </p:txBody>
-      </p:sp>
-      <p:sp>
-        <p:nvSpPr>
-          <p:cNvPr id="20" name="Text 18"/>
-          <p:cNvSpPr/>
-          <p:nvPr/>
-        </p:nvSpPr>
-        <p:spPr>
-          <a:xfrm>
-            <a:off x="1600200" y="4910328"/>
-            <a:ext cx="9692640" cy="384048"/>
-          </a:xfrm>
-          <a:prstGeom prst="rect">
-            <a:avLst/>
-          </a:prstGeom>
-          <a:noFill/>
-          <a:ln/>
-        </p:spPr>
-        <p:txBody>
-          <a:bodyPr wrap="square" lIns="0" tIns="0" rIns="0" bIns="0" rtlCol="0" anchor="ctr"/>
-          <a:lstStyle/>
-          <a:p>
-            <a:pPr indent="0" marL="0">
-              <a:buNone/>
-            </a:pPr>
-            <a:r>
-              <a:rPr lang="en-US" sz="1550" b="1" dirty="0">
-                <a:solidFill>
-                  <a:srgbClr val="6B7280"/>
-                </a:solidFill>
-                <a:latin typeface="Georgia" pitchFamily="34" charset="0"/>
-                <a:ea typeface="Georgia" pitchFamily="34" charset="-122"/>
-                <a:cs typeface="Georgia" pitchFamily="34" charset="-120"/>
-              </a:rPr>
-              <a:t>O ÚNICO SINAL DE DIETA</a:t>
-            </a:r>
-            <a:endParaRPr lang="en-US" sz="1550" dirty="0"/>
-          </a:p>
-        </p:txBody>
-      </p:sp>
-      <p:sp>
-        <p:nvSpPr>
-          <p:cNvPr id="21" name="Text 19"/>
-          <p:cNvSpPr/>
-          <p:nvPr/>
-        </p:nvSpPr>
-        <p:spPr>
-          <a:xfrm>
-            <a:off x="1600200" y="5294376"/>
-            <a:ext cx="9692640" cy="731520"/>
-          </a:xfrm>
-          <a:prstGeom prst="rect">
-            <a:avLst/>
-          </a:prstGeom>
-          <a:noFill/>
-          <a:ln/>
-        </p:spPr>
-        <p:txBody>
-          <a:bodyPr wrap="square" lIns="0" tIns="0" rIns="0" bIns="0" rtlCol="0" anchor="ctr"/>
-          <a:lstStyle/>
-          <a:p>
-            <a:pPr indent="0" marL="0">
-              <a:lnSpc>
-                <a:spcPct val="110000"/>
-              </a:lnSpc>
-              <a:buNone/>
-            </a:pPr>
-            <a:r>
-              <a:rPr lang="en-US" sz="1250" dirty="0">
-                <a:solidFill>
-                  <a:srgbClr val="2B2B2B"/>
-                </a:solidFill>
-                <a:latin typeface="Calibri" pitchFamily="34" charset="0"/>
-                <a:ea typeface="Calibri" pitchFamily="34" charset="-122"/>
-                <a:cs typeface="Calibri" pitchFamily="34" charset="-120"/>
-              </a:rPr>
-              <a:t>É invertido (D2): dieta mais pró-inflamatória associada a MENOS doença → causalidade reversa, não proteção.</a:t>
-            </a:r>
-            <a:endParaRPr lang="en-US" sz="1250" dirty="0"/>
-          </a:p>
-        </p:txBody>
-      </p:sp>
-      <p:sp>
-        <p:nvSpPr>
-          <p:cNvPr id="22" name="Text 20"/>
+              <a:t>o ranking por Incerteza Simétrica (independente do classificador) coloca autoavaliação de saúde, sexo e uso de serviço no topo; a maioria dos itens alimentares fica perto de zero. Três lentes — entropia, Gini e OR — convergem.</a:t>
+            </a:r>
+            <a:endParaRPr lang="en-US" sz="1300" dirty="0"/>
+          </a:p>
+        </p:txBody>
+      </p:sp>
+      <p:sp>
+        <p:nvSpPr>
+          <p:cNvPr id="7" name="Text 4"/>
           <p:cNvSpPr/>
           <p:nvPr/>
         </p:nvSpPr>
@@ -7423,7 +7051,7 @@
       </p:sp>
       <p:sp>
         <p:nvSpPr>
-          <p:cNvPr id="23" name="Text 21"/>
+          <p:cNvPr id="8" name="Text 5"/>
           <p:cNvSpPr/>
           <p:nvPr/>
         </p:nvSpPr>
@@ -7525,7 +7153,7 @@
                 <a:ea typeface="Calibri" pitchFamily="34" charset="-122"/>
                 <a:cs typeface="Calibri" pitchFamily="34" charset="-120"/>
               </a:rPr>
-              <a:t>LIMITAÇÕES · LEITURA HONESTA</a:t>
+              <a:t>DISCUSSÃO · A RESPOSTA À PERGUNTA</a:t>
             </a:r>
             <a:endParaRPr lang="en-US" sz="1200" dirty="0"/>
           </a:p>
@@ -7564,7 +7192,7 @@
                 <a:ea typeface="Georgia" pitchFamily="34" charset="-122"/>
                 <a:cs typeface="Georgia" pitchFamily="34" charset="-120"/>
               </a:rPr>
-              <a:t>Por que o nulo nutricional é esperado</a:t>
+              <a:t>O que diferencia idoso com artrite do saudável</a:t>
             </a:r>
             <a:endParaRPr lang="en-US" sz="3000" dirty="0"/>
           </a:p>
@@ -7579,7 +7207,7 @@
         <p:spPr>
           <a:xfrm>
             <a:off x="640080" y="1783080"/>
-            <a:ext cx="5440680" cy="1143000"/>
+            <a:ext cx="10881360" cy="1371600"/>
           </a:xfrm>
           <a:prstGeom prst="rect">
             <a:avLst/>
@@ -7611,27 +7239,47 @@
         <p:spPr>
           <a:xfrm>
             <a:off x="640080" y="1783080"/>
-            <a:ext cx="82296" cy="1143000"/>
+            <a:ext cx="82296" cy="1371600"/>
           </a:xfrm>
           <a:prstGeom prst="rect">
             <a:avLst/>
           </a:prstGeom>
           <a:solidFill>
-            <a:srgbClr val="E8A33D"/>
+            <a:srgbClr val="27AE60"/>
           </a:solidFill>
           <a:ln/>
         </p:spPr>
       </p:sp>
       <p:sp>
         <p:nvSpPr>
-          <p:cNvPr id="6" name="Text 4"/>
-          <p:cNvSpPr/>
-          <p:nvPr/>
-        </p:nvSpPr>
-        <p:spPr>
-          <a:xfrm>
-            <a:off x="896112" y="1911096"/>
-            <a:ext cx="4983480" cy="365760"/>
+          <p:cNvPr id="6" name="Shape 4"/>
+          <p:cNvSpPr/>
+          <p:nvPr/>
+        </p:nvSpPr>
+        <p:spPr>
+          <a:xfrm>
+            <a:off x="868680" y="2194560"/>
+            <a:ext cx="548640" cy="548640"/>
+          </a:xfrm>
+          <a:prstGeom prst="ellipse">
+            <a:avLst/>
+          </a:prstGeom>
+          <a:solidFill>
+            <a:srgbClr val="27AE60"/>
+          </a:solidFill>
+          <a:ln/>
+        </p:spPr>
+      </p:sp>
+      <p:sp>
+        <p:nvSpPr>
+          <p:cNvPr id="7" name="Text 5"/>
+          <p:cNvSpPr/>
+          <p:nvPr/>
+        </p:nvSpPr>
+        <p:spPr>
+          <a:xfrm>
+            <a:off x="868680" y="2194560"/>
+            <a:ext cx="548640" cy="548640"/>
           </a:xfrm>
           <a:prstGeom prst="rect">
             <a:avLst/>
@@ -7643,34 +7291,73 @@
           <a:bodyPr wrap="square" lIns="0" tIns="0" rIns="0" bIns="0" rtlCol="0" anchor="ctr"/>
           <a:lstStyle/>
           <a:p>
-            <a:pPr indent="0" marL="0">
+            <a:pPr algn="ctr" indent="0" marL="0">
               <a:buNone/>
             </a:pPr>
             <a:r>
-              <a:rPr lang="en-US" sz="1350" b="1" dirty="0">
+              <a:rPr lang="en-US" sz="2200" b="1" dirty="0">
                 <a:solidFill>
-                  <a:srgbClr val="1E2761"/>
+                  <a:srgbClr val="FFFFFF"/>
                 </a:solidFill>
                 <a:latin typeface="Georgia" pitchFamily="34" charset="0"/>
                 <a:ea typeface="Georgia" pitchFamily="34" charset="-122"/>
                 <a:cs typeface="Georgia" pitchFamily="34" charset="-120"/>
               </a:rPr>
-              <a:t>Imputação alta dos itens</a:t>
-            </a:r>
-            <a:endParaRPr lang="en-US" sz="1350" dirty="0"/>
-          </a:p>
-        </p:txBody>
-      </p:sp>
-      <p:sp>
-        <p:nvSpPr>
-          <p:cNvPr id="7" name="Text 5"/>
-          <p:cNvSpPr/>
-          <p:nvPr/>
-        </p:nvSpPr>
-        <p:spPr>
-          <a:xfrm>
-            <a:off x="896112" y="2286000"/>
-            <a:ext cx="4983480" cy="594360"/>
+              <a:t>✓</a:t>
+            </a:r>
+            <a:endParaRPr lang="en-US" sz="2200" dirty="0"/>
+          </a:p>
+        </p:txBody>
+      </p:sp>
+      <p:sp>
+        <p:nvSpPr>
+          <p:cNvPr id="8" name="Text 6"/>
+          <p:cNvSpPr/>
+          <p:nvPr/>
+        </p:nvSpPr>
+        <p:spPr>
+          <a:xfrm>
+            <a:off x="1600200" y="1947672"/>
+            <a:ext cx="9692640" cy="384048"/>
+          </a:xfrm>
+          <a:prstGeom prst="rect">
+            <a:avLst/>
+          </a:prstGeom>
+          <a:noFill/>
+          <a:ln/>
+        </p:spPr>
+        <p:txBody>
+          <a:bodyPr wrap="square" lIns="0" tIns="0" rIns="0" bIns="0" rtlCol="0" anchor="ctr"/>
+          <a:lstStyle/>
+          <a:p>
+            <a:pPr indent="0" marL="0">
+              <a:buNone/>
+            </a:pPr>
+            <a:r>
+              <a:rPr lang="en-US" sz="1550" b="1" dirty="0">
+                <a:solidFill>
+                  <a:srgbClr val="27AE60"/>
+                </a:solidFill>
+                <a:latin typeface="Georgia" pitchFamily="34" charset="0"/>
+                <a:ea typeface="Georgia" pitchFamily="34" charset="-122"/>
+                <a:cs typeface="Georgia" pitchFamily="34" charset="-120"/>
+              </a:rPr>
+              <a:t>DIFERENCIAM</a:t>
+            </a:r>
+            <a:endParaRPr lang="en-US" sz="1550" dirty="0"/>
+          </a:p>
+        </p:txBody>
+      </p:sp>
+      <p:sp>
+        <p:nvSpPr>
+          <p:cNvPr id="9" name="Text 7"/>
+          <p:cNvSpPr/>
+          <p:nvPr/>
+        </p:nvSpPr>
+        <p:spPr>
+          <a:xfrm>
+            <a:off x="1600200" y="2331720"/>
+            <a:ext cx="9692640" cy="731520"/>
           </a:xfrm>
           <a:prstGeom prst="rect">
             <a:avLst/>
@@ -7684,12 +7371,12 @@
           <a:p>
             <a:pPr indent="0" marL="0">
               <a:lnSpc>
-                <a:spcPct val="108000"/>
+                <a:spcPct val="110000"/>
               </a:lnSpc>
               <a:buNone/>
             </a:pPr>
             <a:r>
-              <a:rPr lang="en-US" sz="1150" dirty="0">
+              <a:rPr lang="en-US" sz="1250" dirty="0">
                 <a:solidFill>
                   <a:srgbClr val="2B2B2B"/>
                 </a:solidFill>
@@ -7697,22 +7384,22 @@
                 <a:ea typeface="Calibri" pitchFamily="34" charset="-122"/>
                 <a:cs typeface="Calibri" pitchFamily="34" charset="-120"/>
               </a:rPr>
-              <a:t>57–74% das frequências alimentares foram imputadas → o sinal individual fica diluído.</a:t>
-            </a:r>
-            <a:endParaRPr lang="en-US" sz="1150" dirty="0"/>
-          </a:p>
-        </p:txBody>
-      </p:sp>
-      <p:sp>
-        <p:nvSpPr>
-          <p:cNvPr id="8" name="Shape 6"/>
-          <p:cNvSpPr/>
-          <p:nvPr/>
-        </p:nvSpPr>
-        <p:spPr>
-          <a:xfrm>
-            <a:off x="6355080" y="1783080"/>
-            <a:ext cx="5440680" cy="1143000"/>
+              <a:t>Sexo feminino (OR 2,5–4,7), idade mais avançada e o estado de saúde (comorbidades, limitação funcional, autoavaliação ruim).</a:t>
+            </a:r>
+            <a:endParaRPr lang="en-US" sz="1250" dirty="0"/>
+          </a:p>
+        </p:txBody>
+      </p:sp>
+      <p:sp>
+        <p:nvSpPr>
+          <p:cNvPr id="10" name="Shape 8"/>
+          <p:cNvSpPr/>
+          <p:nvPr/>
+        </p:nvSpPr>
+        <p:spPr>
+          <a:xfrm>
+            <a:off x="640080" y="3264408"/>
+            <a:ext cx="10881360" cy="1371600"/>
           </a:xfrm>
           <a:prstGeom prst="rect">
             <a:avLst/>
@@ -7737,34 +7424,54 @@
       </p:sp>
       <p:sp>
         <p:nvSpPr>
-          <p:cNvPr id="9" name="Shape 7"/>
-          <p:cNvSpPr/>
-          <p:nvPr/>
-        </p:nvSpPr>
-        <p:spPr>
-          <a:xfrm>
-            <a:off x="6355080" y="1783080"/>
-            <a:ext cx="82296" cy="1143000"/>
+          <p:cNvPr id="11" name="Shape 9"/>
+          <p:cNvSpPr/>
+          <p:nvPr/>
+        </p:nvSpPr>
+        <p:spPr>
+          <a:xfrm>
+            <a:off x="640080" y="3264408"/>
+            <a:ext cx="82296" cy="1371600"/>
           </a:xfrm>
           <a:prstGeom prst="rect">
             <a:avLst/>
           </a:prstGeom>
           <a:solidFill>
-            <a:srgbClr val="E8A33D"/>
+            <a:srgbClr val="C0392B"/>
           </a:solidFill>
           <a:ln/>
         </p:spPr>
       </p:sp>
       <p:sp>
         <p:nvSpPr>
-          <p:cNvPr id="10" name="Text 8"/>
-          <p:cNvSpPr/>
-          <p:nvPr/>
-        </p:nvSpPr>
-        <p:spPr>
-          <a:xfrm>
-            <a:off x="6611112" y="1911096"/>
-            <a:ext cx="4983480" cy="365760"/>
+          <p:cNvPr id="12" name="Shape 10"/>
+          <p:cNvSpPr/>
+          <p:nvPr/>
+        </p:nvSpPr>
+        <p:spPr>
+          <a:xfrm>
+            <a:off x="868680" y="3675888"/>
+            <a:ext cx="548640" cy="548640"/>
+          </a:xfrm>
+          <a:prstGeom prst="ellipse">
+            <a:avLst/>
+          </a:prstGeom>
+          <a:solidFill>
+            <a:srgbClr val="C0392B"/>
+          </a:solidFill>
+          <a:ln/>
+        </p:spPr>
+      </p:sp>
+      <p:sp>
+        <p:nvSpPr>
+          <p:cNvPr id="13" name="Text 11"/>
+          <p:cNvSpPr/>
+          <p:nvPr/>
+        </p:nvSpPr>
+        <p:spPr>
+          <a:xfrm>
+            <a:off x="868680" y="3675888"/>
+            <a:ext cx="548640" cy="548640"/>
           </a:xfrm>
           <a:prstGeom prst="rect">
             <a:avLst/>
@@ -7776,34 +7483,73 @@
           <a:bodyPr wrap="square" lIns="0" tIns="0" rIns="0" bIns="0" rtlCol="0" anchor="ctr"/>
           <a:lstStyle/>
           <a:p>
-            <a:pPr indent="0" marL="0">
+            <a:pPr algn="ctr" indent="0" marL="0">
               <a:buNone/>
             </a:pPr>
             <a:r>
-              <a:rPr lang="en-US" sz="1350" b="1" dirty="0">
+              <a:rPr lang="en-US" sz="2200" b="1" dirty="0">
                 <a:solidFill>
-                  <a:srgbClr val="1E2761"/>
+                  <a:srgbClr val="FFFFFF"/>
                 </a:solidFill>
                 <a:latin typeface="Georgia" pitchFamily="34" charset="0"/>
                 <a:ea typeface="Georgia" pitchFamily="34" charset="-122"/>
                 <a:cs typeface="Georgia" pitchFamily="34" charset="-120"/>
               </a:rPr>
-              <a:t>Corte transversal</a:t>
-            </a:r>
-            <a:endParaRPr lang="en-US" sz="1350" dirty="0"/>
-          </a:p>
-        </p:txBody>
-      </p:sp>
-      <p:sp>
-        <p:nvSpPr>
-          <p:cNvPr id="11" name="Text 9"/>
-          <p:cNvSpPr/>
-          <p:nvPr/>
-        </p:nvSpPr>
-        <p:spPr>
-          <a:xfrm>
-            <a:off x="6611112" y="2286000"/>
-            <a:ext cx="4983480" cy="594360"/>
+              <a:t>✕</a:t>
+            </a:r>
+            <a:endParaRPr lang="en-US" sz="2200" dirty="0"/>
+          </a:p>
+        </p:txBody>
+      </p:sp>
+      <p:sp>
+        <p:nvSpPr>
+          <p:cNvPr id="14" name="Text 12"/>
+          <p:cNvSpPr/>
+          <p:nvPr/>
+        </p:nvSpPr>
+        <p:spPr>
+          <a:xfrm>
+            <a:off x="1600200" y="3429000"/>
+            <a:ext cx="9692640" cy="384048"/>
+          </a:xfrm>
+          <a:prstGeom prst="rect">
+            <a:avLst/>
+          </a:prstGeom>
+          <a:noFill/>
+          <a:ln/>
+        </p:spPr>
+        <p:txBody>
+          <a:bodyPr wrap="square" lIns="0" tIns="0" rIns="0" bIns="0" rtlCol="0" anchor="ctr"/>
+          <a:lstStyle/>
+          <a:p>
+            <a:pPr indent="0" marL="0">
+              <a:buNone/>
+            </a:pPr>
+            <a:r>
+              <a:rPr lang="en-US" sz="1550" b="1" dirty="0">
+                <a:solidFill>
+                  <a:srgbClr val="C0392B"/>
+                </a:solidFill>
+                <a:latin typeface="Georgia" pitchFamily="34" charset="0"/>
+                <a:ea typeface="Georgia" pitchFamily="34" charset="-122"/>
+                <a:cs typeface="Georgia" pitchFamily="34" charset="-120"/>
+              </a:rPr>
+              <a:t>NÃO DIFERENCIAM</a:t>
+            </a:r>
+            <a:endParaRPr lang="en-US" sz="1550" dirty="0"/>
+          </a:p>
+        </p:txBody>
+      </p:sp>
+      <p:sp>
+        <p:nvSpPr>
+          <p:cNvPr id="15" name="Text 13"/>
+          <p:cNvSpPr/>
+          <p:nvPr/>
+        </p:nvSpPr>
+        <p:spPr>
+          <a:xfrm>
+            <a:off x="1600200" y="3813048"/>
+            <a:ext cx="9692640" cy="731520"/>
           </a:xfrm>
           <a:prstGeom prst="rect">
             <a:avLst/>
@@ -7817,12 +7563,12 @@
           <a:p>
             <a:pPr indent="0" marL="0">
               <a:lnSpc>
-                <a:spcPct val="108000"/>
+                <a:spcPct val="110000"/>
               </a:lnSpc>
               <a:buNone/>
             </a:pPr>
             <a:r>
-              <a:rPr lang="en-US" sz="1150" dirty="0">
+              <a:rPr lang="en-US" sz="1250" dirty="0">
                 <a:solidFill>
                   <a:srgbClr val="2B2B2B"/>
                 </a:solidFill>
@@ -7830,22 +7576,22 @@
                 <a:ea typeface="Calibri" pitchFamily="34" charset="-122"/>
                 <a:cs typeface="Calibri" pitchFamily="34" charset="-120"/>
               </a:rPr>
-              <a:t>A PNS é uma foto; não capta a dieta de anos antes do diagnóstico (latência da artrite).</a:t>
-            </a:r>
-            <a:endParaRPr lang="en-US" sz="1150" dirty="0"/>
-          </a:p>
-        </p:txBody>
-      </p:sp>
-      <p:sp>
-        <p:nvSpPr>
-          <p:cNvPr id="12" name="Shape 10"/>
-          <p:cNvSpPr/>
-          <p:nvPr/>
-        </p:nvSpPr>
-        <p:spPr>
-          <a:xfrm>
-            <a:off x="640080" y="3108960"/>
-            <a:ext cx="5440680" cy="1143000"/>
+              <a:t>Os padrões nutricionais: ΔF1/ΔAUC ≈ 0 ao acrescentar a dieta; IRNI nunca significativo; itens no fim do ranking.</a:t>
+            </a:r>
+            <a:endParaRPr lang="en-US" sz="1250" dirty="0"/>
+          </a:p>
+        </p:txBody>
+      </p:sp>
+      <p:sp>
+        <p:nvSpPr>
+          <p:cNvPr id="16" name="Shape 14"/>
+          <p:cNvSpPr/>
+          <p:nvPr/>
+        </p:nvSpPr>
+        <p:spPr>
+          <a:xfrm>
+            <a:off x="640080" y="4745736"/>
+            <a:ext cx="10881360" cy="1371600"/>
           </a:xfrm>
           <a:prstGeom prst="rect">
             <a:avLst/>
@@ -7870,34 +7616,93 @@
       </p:sp>
       <p:sp>
         <p:nvSpPr>
-          <p:cNvPr id="13" name="Shape 11"/>
-          <p:cNvSpPr/>
-          <p:nvPr/>
-        </p:nvSpPr>
-        <p:spPr>
-          <a:xfrm>
-            <a:off x="640080" y="3108960"/>
-            <a:ext cx="82296" cy="1143000"/>
+          <p:cNvPr id="17" name="Shape 15"/>
+          <p:cNvSpPr/>
+          <p:nvPr/>
+        </p:nvSpPr>
+        <p:spPr>
+          <a:xfrm>
+            <a:off x="640080" y="4745736"/>
+            <a:ext cx="82296" cy="1371600"/>
           </a:xfrm>
           <a:prstGeom prst="rect">
             <a:avLst/>
           </a:prstGeom>
           <a:solidFill>
-            <a:srgbClr val="E8A33D"/>
+            <a:srgbClr val="6B7280"/>
           </a:solidFill>
           <a:ln/>
         </p:spPr>
       </p:sp>
       <p:sp>
         <p:nvSpPr>
-          <p:cNvPr id="14" name="Text 12"/>
-          <p:cNvSpPr/>
-          <p:nvPr/>
-        </p:nvSpPr>
-        <p:spPr>
-          <a:xfrm>
-            <a:off x="896112" y="3236976"/>
-            <a:ext cx="4983480" cy="365760"/>
+          <p:cNvPr id="18" name="Shape 16"/>
+          <p:cNvSpPr/>
+          <p:nvPr/>
+        </p:nvSpPr>
+        <p:spPr>
+          <a:xfrm>
+            <a:off x="868680" y="5157216"/>
+            <a:ext cx="548640" cy="548640"/>
+          </a:xfrm>
+          <a:prstGeom prst="ellipse">
+            <a:avLst/>
+          </a:prstGeom>
+          <a:solidFill>
+            <a:srgbClr val="6B7280"/>
+          </a:solidFill>
+          <a:ln/>
+        </p:spPr>
+      </p:sp>
+      <p:sp>
+        <p:nvSpPr>
+          <p:cNvPr id="19" name="Text 17"/>
+          <p:cNvSpPr/>
+          <p:nvPr/>
+        </p:nvSpPr>
+        <p:spPr>
+          <a:xfrm>
+            <a:off x="868680" y="5157216"/>
+            <a:ext cx="548640" cy="548640"/>
+          </a:xfrm>
+          <a:prstGeom prst="rect">
+            <a:avLst/>
+          </a:prstGeom>
+          <a:noFill/>
+          <a:ln/>
+        </p:spPr>
+        <p:txBody>
+          <a:bodyPr wrap="square" lIns="0" tIns="0" rIns="0" bIns="0" rtlCol="0" anchor="ctr"/>
+          <a:lstStyle/>
+          <a:p>
+            <a:pPr algn="ctr" indent="0" marL="0">
+              <a:buNone/>
+            </a:pPr>
+            <a:r>
+              <a:rPr lang="en-US" sz="2200" b="1" dirty="0">
+                <a:solidFill>
+                  <a:srgbClr val="FFFFFF"/>
+                </a:solidFill>
+                <a:latin typeface="Georgia" pitchFamily="34" charset="0"/>
+                <a:ea typeface="Georgia" pitchFamily="34" charset="-122"/>
+                <a:cs typeface="Georgia" pitchFamily="34" charset="-120"/>
+              </a:rPr>
+              <a:t>⟲</a:t>
+            </a:r>
+            <a:endParaRPr lang="en-US" sz="2200" dirty="0"/>
+          </a:p>
+        </p:txBody>
+      </p:sp>
+      <p:sp>
+        <p:nvSpPr>
+          <p:cNvPr id="20" name="Text 18"/>
+          <p:cNvSpPr/>
+          <p:nvPr/>
+        </p:nvSpPr>
+        <p:spPr>
+          <a:xfrm>
+            <a:off x="1600200" y="4910328"/>
+            <a:ext cx="9692640" cy="384048"/>
           </a:xfrm>
           <a:prstGeom prst="rect">
             <a:avLst/>
@@ -7913,7 +7718,237 @@
               <a:buNone/>
             </a:pPr>
             <a:r>
-              <a:rPr lang="en-US" sz="1350" b="1" dirty="0">
+              <a:rPr lang="en-US" sz="1550" b="1" dirty="0">
+                <a:solidFill>
+                  <a:srgbClr val="6B7280"/>
+                </a:solidFill>
+                <a:latin typeface="Georgia" pitchFamily="34" charset="0"/>
+                <a:ea typeface="Georgia" pitchFamily="34" charset="-122"/>
+                <a:cs typeface="Georgia" pitchFamily="34" charset="-120"/>
+              </a:rPr>
+              <a:t>O ÚNICO SINAL DE DIETA</a:t>
+            </a:r>
+            <a:endParaRPr lang="en-US" sz="1550" dirty="0"/>
+          </a:p>
+        </p:txBody>
+      </p:sp>
+      <p:sp>
+        <p:nvSpPr>
+          <p:cNvPr id="21" name="Text 19"/>
+          <p:cNvSpPr/>
+          <p:nvPr/>
+        </p:nvSpPr>
+        <p:spPr>
+          <a:xfrm>
+            <a:off x="1600200" y="5294376"/>
+            <a:ext cx="9692640" cy="731520"/>
+          </a:xfrm>
+          <a:prstGeom prst="rect">
+            <a:avLst/>
+          </a:prstGeom>
+          <a:noFill/>
+          <a:ln/>
+        </p:spPr>
+        <p:txBody>
+          <a:bodyPr wrap="square" lIns="0" tIns="0" rIns="0" bIns="0" rtlCol="0" anchor="ctr"/>
+          <a:lstStyle/>
+          <a:p>
+            <a:pPr indent="0" marL="0">
+              <a:lnSpc>
+                <a:spcPct val="110000"/>
+              </a:lnSpc>
+              <a:buNone/>
+            </a:pPr>
+            <a:r>
+              <a:rPr lang="en-US" sz="1250" dirty="0">
+                <a:solidFill>
+                  <a:srgbClr val="2B2B2B"/>
+                </a:solidFill>
+                <a:latin typeface="Calibri" pitchFamily="34" charset="0"/>
+                <a:ea typeface="Calibri" pitchFamily="34" charset="-122"/>
+                <a:cs typeface="Calibri" pitchFamily="34" charset="-120"/>
+              </a:rPr>
+              <a:t>É invertido (D2): dieta mais pró-inflamatória associada a MENOS doença → causalidade reversa, não proteção.</a:t>
+            </a:r>
+            <a:endParaRPr lang="en-US" sz="1250" dirty="0"/>
+          </a:p>
+        </p:txBody>
+      </p:sp>
+      <p:sp>
+        <p:nvSpPr>
+          <p:cNvPr id="22" name="Text 20"/>
+          <p:cNvSpPr/>
+          <p:nvPr/>
+        </p:nvSpPr>
+        <p:spPr>
+          <a:xfrm>
+            <a:off x="640080" y="6473952"/>
+            <a:ext cx="8229600" cy="274320"/>
+          </a:xfrm>
+          <a:prstGeom prst="rect">
+            <a:avLst/>
+          </a:prstGeom>
+          <a:noFill/>
+          <a:ln/>
+        </p:spPr>
+        <p:txBody>
+          <a:bodyPr wrap="square" lIns="0" tIns="0" rIns="0" bIns="0" rtlCol="0" anchor="ctr"/>
+          <a:lstStyle/>
+          <a:p>
+            <a:pPr indent="0" marL="0">
+              <a:buNone/>
+            </a:pPr>
+            <a:r>
+              <a:rPr lang="en-US" sz="900" dirty="0">
+                <a:solidFill>
+                  <a:srgbClr val="6B7280"/>
+                </a:solidFill>
+                <a:latin typeface="Calibri" pitchFamily="34" charset="0"/>
+                <a:ea typeface="Calibri" pitchFamily="34" charset="-122"/>
+                <a:cs typeface="Calibri" pitchFamily="34" charset="-120"/>
+              </a:rPr>
+              <a:t>NB06 §4 · Ablação por blocos — PNS 2019 · Artrite em idosos ≥60</a:t>
+            </a:r>
+            <a:endParaRPr lang="en-US" sz="900" dirty="0"/>
+          </a:p>
+        </p:txBody>
+      </p:sp>
+      <p:sp>
+        <p:nvSpPr>
+          <p:cNvPr id="23" name="Text 21"/>
+          <p:cNvSpPr/>
+          <p:nvPr/>
+        </p:nvSpPr>
+        <p:spPr>
+          <a:xfrm>
+            <a:off x="11247120" y="6473952"/>
+            <a:ext cx="365760" cy="274320"/>
+          </a:xfrm>
+          <a:prstGeom prst="rect">
+            <a:avLst/>
+          </a:prstGeom>
+          <a:noFill/>
+          <a:ln/>
+        </p:spPr>
+        <p:txBody>
+          <a:bodyPr wrap="square" lIns="0" tIns="0" rIns="0" bIns="0" rtlCol="0" anchor="ctr"/>
+          <a:lstStyle/>
+          <a:p>
+            <a:pPr algn="r" indent="0" marL="0">
+              <a:buNone/>
+            </a:pPr>
+            <a:r>
+              <a:rPr lang="en-US" sz="900" dirty="0">
+                <a:solidFill>
+                  <a:srgbClr val="6B7280"/>
+                </a:solidFill>
+                <a:latin typeface="Calibri" pitchFamily="34" charset="0"/>
+                <a:ea typeface="Calibri" pitchFamily="34" charset="-122"/>
+                <a:cs typeface="Calibri" pitchFamily="34" charset="-120"/>
+              </a:rPr>
+              <a:t>14</a:t>
+            </a:r>
+            <a:endParaRPr lang="en-US" sz="900" dirty="0"/>
+          </a:p>
+        </p:txBody>
+      </p:sp>
+    </p:spTree>
+  </p:cSld>
+  <p:clrMapOvr>
+    <a:masterClrMapping/>
+  </p:clrMapOvr>
+</p:sld>
+</file>
+
+<file path=ppt/slides/slide16.xml><?xml version="1.0" encoding="utf-8"?>
+<p:sld xmlns:a="http://schemas.openxmlformats.org/drawingml/2006/main" xmlns:r="http://schemas.openxmlformats.org/officeDocument/2006/relationships" xmlns:p="http://schemas.openxmlformats.org/presentationml/2006/main">
+  <p:cSld name="Slide 16">
+    <p:bg>
+      <p:bgPr>
+        <a:solidFill>
+          <a:srgbClr val="FFFFFF"/>
+        </a:solidFill>
+      </p:bgPr>
+    </p:bg>
+    <p:spTree>
+      <p:nvGrpSpPr>
+        <p:cNvPr id="1" name=""/>
+        <p:cNvGrpSpPr/>
+        <p:nvPr/>
+      </p:nvGrpSpPr>
+      <p:grpSpPr>
+        <a:xfrm>
+          <a:off x="0" y="0"/>
+          <a:ext cx="0" cy="0"/>
+          <a:chOff x="0" y="0"/>
+          <a:chExt cx="0" cy="0"/>
+        </a:xfrm>
+      </p:grpSpPr>
+      <p:sp>
+        <p:nvSpPr>
+          <p:cNvPr id="2" name="Text 0"/>
+          <p:cNvSpPr/>
+          <p:nvPr/>
+        </p:nvSpPr>
+        <p:spPr>
+          <a:xfrm>
+            <a:off x="640080" y="457200"/>
+            <a:ext cx="10972800" cy="292608"/>
+          </a:xfrm>
+          <a:prstGeom prst="rect">
+            <a:avLst/>
+          </a:prstGeom>
+          <a:noFill/>
+          <a:ln/>
+        </p:spPr>
+        <p:txBody>
+          <a:bodyPr wrap="square" lIns="0" tIns="0" rIns="0" bIns="0" rtlCol="0" anchor="ctr"/>
+          <a:lstStyle/>
+          <a:p>
+            <a:pPr indent="0" marL="0">
+              <a:buNone/>
+            </a:pPr>
+            <a:r>
+              <a:rPr lang="en-US" sz="1200" b="1" spc="300" kern="0" dirty="0">
+                <a:solidFill>
+                  <a:srgbClr val="E8A33D"/>
+                </a:solidFill>
+                <a:latin typeface="Calibri" pitchFamily="34" charset="0"/>
+                <a:ea typeface="Calibri" pitchFamily="34" charset="-122"/>
+                <a:cs typeface="Calibri" pitchFamily="34" charset="-120"/>
+              </a:rPr>
+              <a:t>LIMITAÇÕES · LEITURA HONESTA</a:t>
+            </a:r>
+            <a:endParaRPr lang="en-US" sz="1200" dirty="0"/>
+          </a:p>
+        </p:txBody>
+      </p:sp>
+      <p:sp>
+        <p:nvSpPr>
+          <p:cNvPr id="3" name="Text 1"/>
+          <p:cNvSpPr/>
+          <p:nvPr/>
+        </p:nvSpPr>
+        <p:spPr>
+          <a:xfrm>
+            <a:off x="640080" y="777240"/>
+            <a:ext cx="11155680" cy="868680"/>
+          </a:xfrm>
+          <a:prstGeom prst="rect">
+            <a:avLst/>
+          </a:prstGeom>
+          <a:noFill/>
+          <a:ln/>
+        </p:spPr>
+        <p:txBody>
+          <a:bodyPr wrap="square" lIns="0" tIns="0" rIns="0" bIns="0" rtlCol="0" anchor="ctr"/>
+          <a:lstStyle/>
+          <a:p>
+            <a:pPr indent="0" marL="0">
+              <a:buNone/>
+            </a:pPr>
+            <a:r>
+              <a:rPr lang="en-US" sz="3000" b="1" dirty="0">
                 <a:solidFill>
                   <a:srgbClr val="1E2761"/>
                 </a:solidFill>
@@ -7921,63 +7956,21 @@
                 <a:ea typeface="Georgia" pitchFamily="34" charset="-122"/>
                 <a:cs typeface="Georgia" pitchFamily="34" charset="-120"/>
               </a:rPr>
-              <a:t>Causalidade reversa</a:t>
-            </a:r>
-            <a:endParaRPr lang="en-US" sz="1350" dirty="0"/>
-          </a:p>
-        </p:txBody>
-      </p:sp>
-      <p:sp>
-        <p:nvSpPr>
-          <p:cNvPr id="15" name="Text 13"/>
-          <p:cNvSpPr/>
-          <p:nvPr/>
-        </p:nvSpPr>
-        <p:spPr>
-          <a:xfrm>
-            <a:off x="896112" y="3611880"/>
-            <a:ext cx="4983480" cy="594360"/>
-          </a:xfrm>
-          <a:prstGeom prst="rect">
-            <a:avLst/>
-          </a:prstGeom>
-          <a:noFill/>
-          <a:ln/>
-        </p:spPr>
-        <p:txBody>
-          <a:bodyPr wrap="square" lIns="0" tIns="0" rIns="0" bIns="0" rtlCol="0" anchor="ctr"/>
-          <a:lstStyle/>
-          <a:p>
-            <a:pPr indent="0" marL="0">
-              <a:lnSpc>
-                <a:spcPct val="108000"/>
-              </a:lnSpc>
-              <a:buNone/>
-            </a:pPr>
-            <a:r>
-              <a:rPr lang="en-US" sz="1150" dirty="0">
-                <a:solidFill>
-                  <a:srgbClr val="2B2B2B"/>
-                </a:solidFill>
-                <a:latin typeface="Calibri" pitchFamily="34" charset="0"/>
-                <a:ea typeface="Calibri" pitchFamily="34" charset="-122"/>
-                <a:cs typeface="Calibri" pitchFamily="34" charset="-120"/>
-              </a:rPr>
-              <a:t>O diagnóstico muda a dieta (manejo) → contamina a associação, como mostra o Cluster invertido.</a:t>
-            </a:r>
-            <a:endParaRPr lang="en-US" sz="1150" dirty="0"/>
-          </a:p>
-        </p:txBody>
-      </p:sp>
-      <p:sp>
-        <p:nvSpPr>
-          <p:cNvPr id="16" name="Shape 14"/>
-          <p:cNvSpPr/>
-          <p:nvPr/>
-        </p:nvSpPr>
-        <p:spPr>
-          <a:xfrm>
-            <a:off x="6355080" y="3108960"/>
+              <a:t>Por que o nulo nutricional é esperado</a:t>
+            </a:r>
+            <a:endParaRPr lang="en-US" sz="3000" dirty="0"/>
+          </a:p>
+        </p:txBody>
+      </p:sp>
+      <p:sp>
+        <p:nvSpPr>
+          <p:cNvPr id="4" name="Shape 2"/>
+          <p:cNvSpPr/>
+          <p:nvPr/>
+        </p:nvSpPr>
+        <p:spPr>
+          <a:xfrm>
+            <a:off x="640080" y="1783080"/>
             <a:ext cx="5440680" cy="1143000"/>
           </a:xfrm>
           <a:prstGeom prst="rect">
@@ -8003,13 +7996,13 @@
       </p:sp>
       <p:sp>
         <p:nvSpPr>
-          <p:cNvPr id="17" name="Shape 15"/>
-          <p:cNvSpPr/>
-          <p:nvPr/>
-        </p:nvSpPr>
-        <p:spPr>
-          <a:xfrm>
-            <a:off x="6355080" y="3108960"/>
+          <p:cNvPr id="5" name="Shape 3"/>
+          <p:cNvSpPr/>
+          <p:nvPr/>
+        </p:nvSpPr>
+        <p:spPr>
+          <a:xfrm>
+            <a:off x="640080" y="1783080"/>
             <a:ext cx="82296" cy="1143000"/>
           </a:xfrm>
           <a:prstGeom prst="rect">
@@ -8023,13 +8016,13 @@
       </p:sp>
       <p:sp>
         <p:nvSpPr>
-          <p:cNvPr id="18" name="Text 16"/>
-          <p:cNvSpPr/>
-          <p:nvPr/>
-        </p:nvSpPr>
-        <p:spPr>
-          <a:xfrm>
-            <a:off x="6611112" y="3236976"/>
+          <p:cNvPr id="6" name="Text 4"/>
+          <p:cNvSpPr/>
+          <p:nvPr/>
+        </p:nvSpPr>
+        <p:spPr>
+          <a:xfrm>
+            <a:off x="896112" y="1911096"/>
             <a:ext cx="4983480" cy="365760"/>
           </a:xfrm>
           <a:prstGeom prst="rect">
@@ -8054,7 +8047,7 @@
                 <a:ea typeface="Georgia" pitchFamily="34" charset="-122"/>
                 <a:cs typeface="Georgia" pitchFamily="34" charset="-120"/>
               </a:rPr>
-              <a:t>Sem tipologia forte</a:t>
+              <a:t>Imputação alta dos itens</a:t>
             </a:r>
             <a:endParaRPr lang="en-US" sz="1350" dirty="0"/>
           </a:p>
@@ -8062,13 +8055,13 @@
       </p:sp>
       <p:sp>
         <p:nvSpPr>
-          <p:cNvPr id="19" name="Text 17"/>
-          <p:cNvSpPr/>
-          <p:nvPr/>
-        </p:nvSpPr>
-        <p:spPr>
-          <a:xfrm>
-            <a:off x="6611112" y="3611880"/>
+          <p:cNvPr id="7" name="Text 5"/>
+          <p:cNvSpPr/>
+          <p:nvPr/>
+        </p:nvSpPr>
+        <p:spPr>
+          <a:xfrm>
+            <a:off x="896112" y="2286000"/>
             <a:ext cx="4983480" cy="594360"/>
           </a:xfrm>
           <a:prstGeom prst="rect">
@@ -8096,7 +8089,7 @@
                 <a:ea typeface="Calibri" pitchFamily="34" charset="-122"/>
                 <a:cs typeface="Calibri" pitchFamily="34" charset="-120"/>
               </a:rPr>
-              <a:t>As silhuetas do k-means são baixas (~0,10): não há padrões alimentares naturais nítidos.</a:t>
+              <a:t>57–74% das frequências alimentares foram imputadas → o sinal individual fica diluído.</a:t>
             </a:r>
             <a:endParaRPr lang="en-US" sz="1150" dirty="0"/>
           </a:p>
@@ -8104,13 +8097,13 @@
       </p:sp>
       <p:sp>
         <p:nvSpPr>
-          <p:cNvPr id="20" name="Shape 18"/>
-          <p:cNvSpPr/>
-          <p:nvPr/>
-        </p:nvSpPr>
-        <p:spPr>
-          <a:xfrm>
-            <a:off x="640080" y="4434840"/>
+          <p:cNvPr id="8" name="Shape 6"/>
+          <p:cNvSpPr/>
+          <p:nvPr/>
+        </p:nvSpPr>
+        <p:spPr>
+          <a:xfrm>
+            <a:off x="6355080" y="1783080"/>
             <a:ext cx="5440680" cy="1143000"/>
           </a:xfrm>
           <a:prstGeom prst="rect">
@@ -8136,13 +8129,13 @@
       </p:sp>
       <p:sp>
         <p:nvSpPr>
-          <p:cNvPr id="21" name="Shape 19"/>
-          <p:cNvSpPr/>
-          <p:nvPr/>
-        </p:nvSpPr>
-        <p:spPr>
-          <a:xfrm>
-            <a:off x="640080" y="4434840"/>
+          <p:cNvPr id="9" name="Shape 7"/>
+          <p:cNvSpPr/>
+          <p:nvPr/>
+        </p:nvSpPr>
+        <p:spPr>
+          <a:xfrm>
+            <a:off x="6355080" y="1783080"/>
             <a:ext cx="82296" cy="1143000"/>
           </a:xfrm>
           <a:prstGeom prst="rect">
@@ -8156,13 +8149,13 @@
       </p:sp>
       <p:sp>
         <p:nvSpPr>
-          <p:cNvPr id="22" name="Text 20"/>
-          <p:cNvSpPr/>
-          <p:nvPr/>
-        </p:nvSpPr>
-        <p:spPr>
-          <a:xfrm>
-            <a:off x="896112" y="4562856"/>
+          <p:cNvPr id="10" name="Text 8"/>
+          <p:cNvSpPr/>
+          <p:nvPr/>
+        </p:nvSpPr>
+        <p:spPr>
+          <a:xfrm>
+            <a:off x="6611112" y="1911096"/>
             <a:ext cx="4983480" cy="365760"/>
           </a:xfrm>
           <a:prstGeom prst="rect">
@@ -8187,7 +8180,7 @@
                 <a:ea typeface="Georgia" pitchFamily="34" charset="-122"/>
                 <a:cs typeface="Georgia" pitchFamily="34" charset="-120"/>
               </a:rPr>
-              <a:t>IRNI ≠ DII validado</a:t>
+              <a:t>Corte transversal</a:t>
             </a:r>
             <a:endParaRPr lang="en-US" sz="1350" dirty="0"/>
           </a:p>
@@ -8195,13 +8188,13 @@
       </p:sp>
       <p:sp>
         <p:nvSpPr>
-          <p:cNvPr id="23" name="Text 21"/>
-          <p:cNvSpPr/>
-          <p:nvPr/>
-        </p:nvSpPr>
-        <p:spPr>
-          <a:xfrm>
-            <a:off x="896112" y="4937760"/>
+          <p:cNvPr id="11" name="Text 9"/>
+          <p:cNvSpPr/>
+          <p:nvPr/>
+        </p:nvSpPr>
+        <p:spPr>
+          <a:xfrm>
+            <a:off x="6611112" y="2286000"/>
             <a:ext cx="4983480" cy="594360"/>
           </a:xfrm>
           <a:prstGeom prst="rect">
@@ -8229,7 +8222,7 @@
                 <a:ea typeface="Calibri" pitchFamily="34" charset="-122"/>
                 <a:cs typeface="Calibri" pitchFamily="34" charset="-120"/>
               </a:rPr>
-              <a:t>Proxy adaptado (frequência, não g/dia; 12 itens) — captura direção, não a magnitude do DII.</a:t>
+              <a:t>A PNS é uma foto; não capta a dieta de anos antes do diagnóstico (latência da artrite).</a:t>
             </a:r>
             <a:endParaRPr lang="en-US" sz="1150" dirty="0"/>
           </a:p>
@@ -8237,13 +8230,13 @@
       </p:sp>
       <p:sp>
         <p:nvSpPr>
-          <p:cNvPr id="24" name="Shape 22"/>
-          <p:cNvSpPr/>
-          <p:nvPr/>
-        </p:nvSpPr>
-        <p:spPr>
-          <a:xfrm>
-            <a:off x="6355080" y="4434840"/>
+          <p:cNvPr id="12" name="Shape 10"/>
+          <p:cNvSpPr/>
+          <p:nvPr/>
+        </p:nvSpPr>
+        <p:spPr>
+          <a:xfrm>
+            <a:off x="640080" y="3108960"/>
             <a:ext cx="5440680" cy="1143000"/>
           </a:xfrm>
           <a:prstGeom prst="rect">
@@ -8269,6 +8262,405 @@
       </p:sp>
       <p:sp>
         <p:nvSpPr>
+          <p:cNvPr id="13" name="Shape 11"/>
+          <p:cNvSpPr/>
+          <p:nvPr/>
+        </p:nvSpPr>
+        <p:spPr>
+          <a:xfrm>
+            <a:off x="640080" y="3108960"/>
+            <a:ext cx="82296" cy="1143000"/>
+          </a:xfrm>
+          <a:prstGeom prst="rect">
+            <a:avLst/>
+          </a:prstGeom>
+          <a:solidFill>
+            <a:srgbClr val="E8A33D"/>
+          </a:solidFill>
+          <a:ln/>
+        </p:spPr>
+      </p:sp>
+      <p:sp>
+        <p:nvSpPr>
+          <p:cNvPr id="14" name="Text 12"/>
+          <p:cNvSpPr/>
+          <p:nvPr/>
+        </p:nvSpPr>
+        <p:spPr>
+          <a:xfrm>
+            <a:off x="896112" y="3236976"/>
+            <a:ext cx="4983480" cy="365760"/>
+          </a:xfrm>
+          <a:prstGeom prst="rect">
+            <a:avLst/>
+          </a:prstGeom>
+          <a:noFill/>
+          <a:ln/>
+        </p:spPr>
+        <p:txBody>
+          <a:bodyPr wrap="square" lIns="0" tIns="0" rIns="0" bIns="0" rtlCol="0" anchor="ctr"/>
+          <a:lstStyle/>
+          <a:p>
+            <a:pPr indent="0" marL="0">
+              <a:buNone/>
+            </a:pPr>
+            <a:r>
+              <a:rPr lang="en-US" sz="1350" b="1" dirty="0">
+                <a:solidFill>
+                  <a:srgbClr val="1E2761"/>
+                </a:solidFill>
+                <a:latin typeface="Georgia" pitchFamily="34" charset="0"/>
+                <a:ea typeface="Georgia" pitchFamily="34" charset="-122"/>
+                <a:cs typeface="Georgia" pitchFamily="34" charset="-120"/>
+              </a:rPr>
+              <a:t>Causalidade reversa</a:t>
+            </a:r>
+            <a:endParaRPr lang="en-US" sz="1350" dirty="0"/>
+          </a:p>
+        </p:txBody>
+      </p:sp>
+      <p:sp>
+        <p:nvSpPr>
+          <p:cNvPr id="15" name="Text 13"/>
+          <p:cNvSpPr/>
+          <p:nvPr/>
+        </p:nvSpPr>
+        <p:spPr>
+          <a:xfrm>
+            <a:off x="896112" y="3611880"/>
+            <a:ext cx="4983480" cy="594360"/>
+          </a:xfrm>
+          <a:prstGeom prst="rect">
+            <a:avLst/>
+          </a:prstGeom>
+          <a:noFill/>
+          <a:ln/>
+        </p:spPr>
+        <p:txBody>
+          <a:bodyPr wrap="square" lIns="0" tIns="0" rIns="0" bIns="0" rtlCol="0" anchor="ctr"/>
+          <a:lstStyle/>
+          <a:p>
+            <a:pPr indent="0" marL="0">
+              <a:lnSpc>
+                <a:spcPct val="108000"/>
+              </a:lnSpc>
+              <a:buNone/>
+            </a:pPr>
+            <a:r>
+              <a:rPr lang="en-US" sz="1150" dirty="0">
+                <a:solidFill>
+                  <a:srgbClr val="2B2B2B"/>
+                </a:solidFill>
+                <a:latin typeface="Calibri" pitchFamily="34" charset="0"/>
+                <a:ea typeface="Calibri" pitchFamily="34" charset="-122"/>
+                <a:cs typeface="Calibri" pitchFamily="34" charset="-120"/>
+              </a:rPr>
+              <a:t>O diagnóstico muda a dieta (manejo) → contamina a associação, como mostra o Cluster invertido.</a:t>
+            </a:r>
+            <a:endParaRPr lang="en-US" sz="1150" dirty="0"/>
+          </a:p>
+        </p:txBody>
+      </p:sp>
+      <p:sp>
+        <p:nvSpPr>
+          <p:cNvPr id="16" name="Shape 14"/>
+          <p:cNvSpPr/>
+          <p:nvPr/>
+        </p:nvSpPr>
+        <p:spPr>
+          <a:xfrm>
+            <a:off x="6355080" y="3108960"/>
+            <a:ext cx="5440680" cy="1143000"/>
+          </a:xfrm>
+          <a:prstGeom prst="rect">
+            <a:avLst/>
+          </a:prstGeom>
+          <a:solidFill>
+            <a:srgbClr val="F4F6FB"/>
+          </a:solidFill>
+          <a:ln w="12700">
+            <a:solidFill>
+              <a:srgbClr val="E3E8F5"/>
+            </a:solidFill>
+            <a:prstDash val="solid"/>
+          </a:ln>
+          <a:effectLst>
+            <a:outerShdw sx="100000" sy="100000" kx="0" ky="0" algn="bl" rotWithShape="0" blurRad="88900" dist="38100" dir="8100000">
+              <a:srgbClr val="000000">
+                <a:alpha val="16000"/>
+              </a:srgbClr>
+            </a:outerShdw>
+          </a:effectLst>
+        </p:spPr>
+      </p:sp>
+      <p:sp>
+        <p:nvSpPr>
+          <p:cNvPr id="17" name="Shape 15"/>
+          <p:cNvSpPr/>
+          <p:nvPr/>
+        </p:nvSpPr>
+        <p:spPr>
+          <a:xfrm>
+            <a:off x="6355080" y="3108960"/>
+            <a:ext cx="82296" cy="1143000"/>
+          </a:xfrm>
+          <a:prstGeom prst="rect">
+            <a:avLst/>
+          </a:prstGeom>
+          <a:solidFill>
+            <a:srgbClr val="E8A33D"/>
+          </a:solidFill>
+          <a:ln/>
+        </p:spPr>
+      </p:sp>
+      <p:sp>
+        <p:nvSpPr>
+          <p:cNvPr id="18" name="Text 16"/>
+          <p:cNvSpPr/>
+          <p:nvPr/>
+        </p:nvSpPr>
+        <p:spPr>
+          <a:xfrm>
+            <a:off x="6611112" y="3236976"/>
+            <a:ext cx="4983480" cy="365760"/>
+          </a:xfrm>
+          <a:prstGeom prst="rect">
+            <a:avLst/>
+          </a:prstGeom>
+          <a:noFill/>
+          <a:ln/>
+        </p:spPr>
+        <p:txBody>
+          <a:bodyPr wrap="square" lIns="0" tIns="0" rIns="0" bIns="0" rtlCol="0" anchor="ctr"/>
+          <a:lstStyle/>
+          <a:p>
+            <a:pPr indent="0" marL="0">
+              <a:buNone/>
+            </a:pPr>
+            <a:r>
+              <a:rPr lang="en-US" sz="1350" b="1" dirty="0">
+                <a:solidFill>
+                  <a:srgbClr val="1E2761"/>
+                </a:solidFill>
+                <a:latin typeface="Georgia" pitchFamily="34" charset="0"/>
+                <a:ea typeface="Georgia" pitchFamily="34" charset="-122"/>
+                <a:cs typeface="Georgia" pitchFamily="34" charset="-120"/>
+              </a:rPr>
+              <a:t>Sem tipologia forte</a:t>
+            </a:r>
+            <a:endParaRPr lang="en-US" sz="1350" dirty="0"/>
+          </a:p>
+        </p:txBody>
+      </p:sp>
+      <p:sp>
+        <p:nvSpPr>
+          <p:cNvPr id="19" name="Text 17"/>
+          <p:cNvSpPr/>
+          <p:nvPr/>
+        </p:nvSpPr>
+        <p:spPr>
+          <a:xfrm>
+            <a:off x="6611112" y="3611880"/>
+            <a:ext cx="4983480" cy="594360"/>
+          </a:xfrm>
+          <a:prstGeom prst="rect">
+            <a:avLst/>
+          </a:prstGeom>
+          <a:noFill/>
+          <a:ln/>
+        </p:spPr>
+        <p:txBody>
+          <a:bodyPr wrap="square" lIns="0" tIns="0" rIns="0" bIns="0" rtlCol="0" anchor="ctr"/>
+          <a:lstStyle/>
+          <a:p>
+            <a:pPr indent="0" marL="0">
+              <a:lnSpc>
+                <a:spcPct val="108000"/>
+              </a:lnSpc>
+              <a:buNone/>
+            </a:pPr>
+            <a:r>
+              <a:rPr lang="en-US" sz="1150" dirty="0">
+                <a:solidFill>
+                  <a:srgbClr val="2B2B2B"/>
+                </a:solidFill>
+                <a:latin typeface="Calibri" pitchFamily="34" charset="0"/>
+                <a:ea typeface="Calibri" pitchFamily="34" charset="-122"/>
+                <a:cs typeface="Calibri" pitchFamily="34" charset="-120"/>
+              </a:rPr>
+              <a:t>As silhuetas do k-means são baixas (~0,10): não há padrões alimentares naturais nítidos.</a:t>
+            </a:r>
+            <a:endParaRPr lang="en-US" sz="1150" dirty="0"/>
+          </a:p>
+        </p:txBody>
+      </p:sp>
+      <p:sp>
+        <p:nvSpPr>
+          <p:cNvPr id="20" name="Shape 18"/>
+          <p:cNvSpPr/>
+          <p:nvPr/>
+        </p:nvSpPr>
+        <p:spPr>
+          <a:xfrm>
+            <a:off x="640080" y="4434840"/>
+            <a:ext cx="5440680" cy="1143000"/>
+          </a:xfrm>
+          <a:prstGeom prst="rect">
+            <a:avLst/>
+          </a:prstGeom>
+          <a:solidFill>
+            <a:srgbClr val="F4F6FB"/>
+          </a:solidFill>
+          <a:ln w="12700">
+            <a:solidFill>
+              <a:srgbClr val="E3E8F5"/>
+            </a:solidFill>
+            <a:prstDash val="solid"/>
+          </a:ln>
+          <a:effectLst>
+            <a:outerShdw sx="100000" sy="100000" kx="0" ky="0" algn="bl" rotWithShape="0" blurRad="88900" dist="38100" dir="8100000">
+              <a:srgbClr val="000000">
+                <a:alpha val="16000"/>
+              </a:srgbClr>
+            </a:outerShdw>
+          </a:effectLst>
+        </p:spPr>
+      </p:sp>
+      <p:sp>
+        <p:nvSpPr>
+          <p:cNvPr id="21" name="Shape 19"/>
+          <p:cNvSpPr/>
+          <p:nvPr/>
+        </p:nvSpPr>
+        <p:spPr>
+          <a:xfrm>
+            <a:off x="640080" y="4434840"/>
+            <a:ext cx="82296" cy="1143000"/>
+          </a:xfrm>
+          <a:prstGeom prst="rect">
+            <a:avLst/>
+          </a:prstGeom>
+          <a:solidFill>
+            <a:srgbClr val="E8A33D"/>
+          </a:solidFill>
+          <a:ln/>
+        </p:spPr>
+      </p:sp>
+      <p:sp>
+        <p:nvSpPr>
+          <p:cNvPr id="22" name="Text 20"/>
+          <p:cNvSpPr/>
+          <p:nvPr/>
+        </p:nvSpPr>
+        <p:spPr>
+          <a:xfrm>
+            <a:off x="896112" y="4562856"/>
+            <a:ext cx="4983480" cy="365760"/>
+          </a:xfrm>
+          <a:prstGeom prst="rect">
+            <a:avLst/>
+          </a:prstGeom>
+          <a:noFill/>
+          <a:ln/>
+        </p:spPr>
+        <p:txBody>
+          <a:bodyPr wrap="square" lIns="0" tIns="0" rIns="0" bIns="0" rtlCol="0" anchor="ctr"/>
+          <a:lstStyle/>
+          <a:p>
+            <a:pPr indent="0" marL="0">
+              <a:buNone/>
+            </a:pPr>
+            <a:r>
+              <a:rPr lang="en-US" sz="1350" b="1" dirty="0">
+                <a:solidFill>
+                  <a:srgbClr val="1E2761"/>
+                </a:solidFill>
+                <a:latin typeface="Georgia" pitchFamily="34" charset="0"/>
+                <a:ea typeface="Georgia" pitchFamily="34" charset="-122"/>
+                <a:cs typeface="Georgia" pitchFamily="34" charset="-120"/>
+              </a:rPr>
+              <a:t>IRNI ≠ DII validado</a:t>
+            </a:r>
+            <a:endParaRPr lang="en-US" sz="1350" dirty="0"/>
+          </a:p>
+        </p:txBody>
+      </p:sp>
+      <p:sp>
+        <p:nvSpPr>
+          <p:cNvPr id="23" name="Text 21"/>
+          <p:cNvSpPr/>
+          <p:nvPr/>
+        </p:nvSpPr>
+        <p:spPr>
+          <a:xfrm>
+            <a:off x="896112" y="4937760"/>
+            <a:ext cx="4983480" cy="594360"/>
+          </a:xfrm>
+          <a:prstGeom prst="rect">
+            <a:avLst/>
+          </a:prstGeom>
+          <a:noFill/>
+          <a:ln/>
+        </p:spPr>
+        <p:txBody>
+          <a:bodyPr wrap="square" lIns="0" tIns="0" rIns="0" bIns="0" rtlCol="0" anchor="ctr"/>
+          <a:lstStyle/>
+          <a:p>
+            <a:pPr indent="0" marL="0">
+              <a:lnSpc>
+                <a:spcPct val="108000"/>
+              </a:lnSpc>
+              <a:buNone/>
+            </a:pPr>
+            <a:r>
+              <a:rPr lang="en-US" sz="1150" dirty="0">
+                <a:solidFill>
+                  <a:srgbClr val="2B2B2B"/>
+                </a:solidFill>
+                <a:latin typeface="Calibri" pitchFamily="34" charset="0"/>
+                <a:ea typeface="Calibri" pitchFamily="34" charset="-122"/>
+                <a:cs typeface="Calibri" pitchFamily="34" charset="-120"/>
+              </a:rPr>
+              <a:t>Proxy adaptado (frequência, não g/dia; 12 itens) — captura direção, não a magnitude do DII.</a:t>
+            </a:r>
+            <a:endParaRPr lang="en-US" sz="1150" dirty="0"/>
+          </a:p>
+        </p:txBody>
+      </p:sp>
+      <p:sp>
+        <p:nvSpPr>
+          <p:cNvPr id="24" name="Shape 22"/>
+          <p:cNvSpPr/>
+          <p:nvPr/>
+        </p:nvSpPr>
+        <p:spPr>
+          <a:xfrm>
+            <a:off x="6355080" y="4434840"/>
+            <a:ext cx="5440680" cy="1143000"/>
+          </a:xfrm>
+          <a:prstGeom prst="rect">
+            <a:avLst/>
+          </a:prstGeom>
+          <a:solidFill>
+            <a:srgbClr val="F4F6FB"/>
+          </a:solidFill>
+          <a:ln w="12700">
+            <a:solidFill>
+              <a:srgbClr val="E3E8F5"/>
+            </a:solidFill>
+            <a:prstDash val="solid"/>
+          </a:ln>
+          <a:effectLst>
+            <a:outerShdw sx="100000" sy="100000" kx="0" ky="0" algn="bl" rotWithShape="0" blurRad="88900" dist="38100" dir="8100000">
+              <a:srgbClr val="000000">
+                <a:alpha val="16000"/>
+              </a:srgbClr>
+            </a:outerShdw>
+          </a:effectLst>
+        </p:spPr>
+      </p:sp>
+      <p:sp>
+        <p:nvSpPr>
           <p:cNvPr id="25" name="Shape 23"/>
           <p:cNvSpPr/>
           <p:nvPr/>
@@ -8440,7 +8832,7 @@
                 <a:ea typeface="Calibri" pitchFamily="34" charset="-122"/>
                 <a:cs typeface="Calibri" pitchFamily="34" charset="-120"/>
               </a:rPr>
-              <a:t>14</a:t>
+              <a:t>15</a:t>
             </a:r>
             <a:endParaRPr lang="en-US" sz="900" dirty="0"/>
           </a:p>
@@ -8454,9 +8846,9 @@
 </p:sld>
 </file>
 
-<file path=ppt/slides/slide16.xml><?xml version="1.0" encoding="utf-8"?>
+<file path=ppt/slides/slide17.xml><?xml version="1.0" encoding="utf-8"?>
 <p:sld xmlns:a="http://schemas.openxmlformats.org/drawingml/2006/main" xmlns:r="http://schemas.openxmlformats.org/officeDocument/2006/relationships" xmlns:p="http://schemas.openxmlformats.org/presentationml/2006/main">
-  <p:cSld name="Slide 16">
+  <p:cSld name="Slide 17">
     <p:bg>
       <p:bgPr>
         <a:solidFill>
@@ -9147,9 +9539,9 @@
 </p:sld>
 </file>
 
-<file path=ppt/slides/slide17.xml><?xml version="1.0" encoding="utf-8"?>
+<file path=ppt/slides/slide18.xml><?xml version="1.0" encoding="utf-8"?>
 <p:sld xmlns:a="http://schemas.openxmlformats.org/drawingml/2006/main" xmlns:r="http://schemas.openxmlformats.org/officeDocument/2006/relationships" xmlns:p="http://schemas.openxmlformats.org/presentationml/2006/main">
-  <p:cSld name="Slide 17">
+  <p:cSld name="Slide 18">
     <p:bg>
       <p:bgPr>
         <a:solidFill>
@@ -9715,7 +10107,7 @@
                 <a:ea typeface="Calibri" pitchFamily="34" charset="-122"/>
                 <a:cs typeface="Calibri" pitchFamily="34" charset="-120"/>
               </a:rPr>
-              <a:t>15</a:t>
+              <a:t>16</a:t>
             </a:r>
             <a:endParaRPr lang="en-US" sz="900" dirty="0"/>
           </a:p>
@@ -17587,7 +17979,7 @@
                 <a:ea typeface="Calibri" pitchFamily="34" charset="-122"/>
                 <a:cs typeface="Calibri" pitchFamily="34" charset="-120"/>
               </a:rPr>
-              <a:t>RESULTADO 3 · IMPORTÂNCIA POR BLOCO (FLORESTA · M3)</a:t>
+              <a:t>RESULTADO 2 · ANÁLISE DE ERRO (DESENHO 1)</a:t>
             </a:r>
             <a:endParaRPr lang="en-US" sz="1200" dirty="0"/>
           </a:p>
@@ -17626,78 +18018,22 @@
                 <a:ea typeface="Georgia" pitchFamily="34" charset="-122"/>
                 <a:cs typeface="Georgia" pitchFamily="34" charset="-120"/>
               </a:rPr>
-              <a:t>O topo do ranking é sexo e saúde, não comida</a:t>
+              <a:t>Por que a F1 do Desenho 1 é baixa</a:t>
             </a:r>
             <a:endParaRPr lang="en-US" sz="3000" dirty="0"/>
           </a:p>
         </p:txBody>
       </p:sp>
-      <p:pic>
-        <p:nvPicPr>
-          <p:cNvPr id="4" name="Image 0" descr="figuras/modelagem_importancia_bloco.png">    </p:cNvPr>
-          <p:cNvPicPr>
-            <a:picLocks noChangeAspect="1"/>
-          </p:cNvPicPr>
-          <p:nvPr/>
-        </p:nvPicPr>
-        <p:blipFill>
-          <a:blip r:embed="rId1"/>
-          <a:stretch>
-            <a:fillRect/>
-          </a:stretch>
-        </p:blipFill>
-        <p:spPr>
-          <a:xfrm>
-            <a:off x="1280160" y="1737360"/>
-            <a:ext cx="9601200" cy="3840480"/>
-          </a:xfrm>
-          <a:prstGeom prst="rect">
-            <a:avLst/>
-          </a:prstGeom>
-          <a:effectLst>
-            <a:outerShdw sx="100000" sy="100000" kx="0" ky="0" algn="bl" rotWithShape="0" blurRad="88900" dist="38100" dir="8100000">
-              <a:srgbClr val="000000">
-                <a:alpha val="16000"/>
-              </a:srgbClr>
-            </a:outerShdw>
-          </a:effectLst>
-        </p:spPr>
-      </p:pic>
-      <p:sp>
-        <p:nvSpPr>
-          <p:cNvPr id="5" name="Shape 2"/>
-          <p:cNvSpPr/>
-          <p:nvPr/>
-        </p:nvSpPr>
-        <p:spPr>
-          <a:xfrm>
-            <a:off x="640080" y="5760720"/>
-            <a:ext cx="10881360" cy="713232"/>
-          </a:xfrm>
-          <a:prstGeom prst="rect">
-            <a:avLst/>
-          </a:prstGeom>
-          <a:solidFill>
-            <a:srgbClr val="EEF6F0"/>
-          </a:solidFill>
-          <a:ln w="12700">
-            <a:solidFill>
-              <a:srgbClr val="2980B9"/>
-            </a:solidFill>
-            <a:prstDash val="solid"/>
-          </a:ln>
-        </p:spPr>
-      </p:sp>
-      <p:sp>
-        <p:nvSpPr>
-          <p:cNvPr id="6" name="Text 3"/>
-          <p:cNvSpPr/>
-          <p:nvPr/>
-        </p:nvSpPr>
-        <p:spPr>
-          <a:xfrm>
-            <a:off x="868680" y="5797296"/>
-            <a:ext cx="10424160" cy="640080"/>
+      <p:sp>
+        <p:nvSpPr>
+          <p:cNvPr id="4" name="Text 2"/>
+          <p:cNvSpPr/>
+          <p:nvPr/>
+        </p:nvSpPr>
+        <p:spPr>
+          <a:xfrm>
+            <a:off x="640080" y="1481328"/>
+            <a:ext cx="10972800" cy="320040"/>
           </a:xfrm>
           <a:prstGeom prst="rect">
             <a:avLst/>
@@ -17710,26 +18046,20 @@
           <a:lstStyle/>
           <a:p>
             <a:pPr indent="0" marL="0">
-              <a:lnSpc>
-                <a:spcPct val="106000"/>
-              </a:lnSpc>
               <a:buNone/>
             </a:pPr>
             <a:r>
               <a:rPr lang="en-US" sz="1300" b="1" dirty="0">
                 <a:solidFill>
-                  <a:srgbClr val="2980B9"/>
+                  <a:srgbClr val="6B7280"/>
                 </a:solidFill>
                 <a:latin typeface="Calibri" pitchFamily="34" charset="0"/>
                 <a:ea typeface="Calibri" pitchFamily="34" charset="-122"/>
                 <a:cs typeface="Calibri" pitchFamily="34" charset="-120"/>
               </a:rPr>
-              <a:t>O que isso significa:  </a:t>
+              <a:t>Matriz: </a:t>
             </a:r>
             <a:pPr indent="0" marL="0">
-              <a:lnSpc>
-                <a:spcPct val="106000"/>
-              </a:lnSpc>
               <a:buNone/>
             </a:pPr>
             <a:r>
@@ -17741,15 +18071,158 @@
                 <a:ea typeface="Calibri" pitchFamily="34" charset="-122"/>
                 <a:cs typeface="Calibri" pitchFamily="34" charset="-120"/>
               </a:rPr>
-              <a:t>as variáveis de maior importância são de CONTROLE (autoavaliação de saúde, consultas, problema de coluna) e SOCIO (sexo, azul). As verdes (nutrição) aparecem no fim — coerente com a entropia (§3) e com o Δ ≈ 0.</a:t>
+              <a:t>recall 0,65 (acha 64 dos 99 doentes) · precisão 0,15 · </a:t>
+            </a:r>
+            <a:pPr indent="0" marL="0">
+              <a:buNone/>
+            </a:pPr>
+            <a:r>
+              <a:rPr lang="en-US" sz="1300" b="1" dirty="0">
+                <a:solidFill>
+                  <a:srgbClr val="C0392B"/>
+                </a:solidFill>
+                <a:latin typeface="Calibri" pitchFamily="34" charset="0"/>
+                <a:ea typeface="Calibri" pitchFamily="34" charset="-122"/>
+                <a:cs typeface="Calibri" pitchFamily="34" charset="-120"/>
+              </a:rPr>
+              <a:t>375 falsos-positivos</a:t>
+            </a:r>
+            <a:pPr indent="0" marL="0">
+              <a:buNone/>
+            </a:pPr>
+            <a:r>
+              <a:rPr lang="en-US" sz="1300" dirty="0">
+                <a:solidFill>
+                  <a:srgbClr val="2B2B2B"/>
+                </a:solidFill>
+                <a:latin typeface="Calibri" pitchFamily="34" charset="0"/>
+                <a:ea typeface="Calibri" pitchFamily="34" charset="-122"/>
+                <a:cs typeface="Calibri" pitchFamily="34" charset="-120"/>
+              </a:rPr>
+              <a:t> — o erro é quase todo FP.</a:t>
             </a:r>
             <a:endParaRPr lang="en-US" sz="1300" dirty="0"/>
           </a:p>
         </p:txBody>
       </p:sp>
+      <p:pic>
+        <p:nvPicPr>
+          <p:cNvPr id="5" name="Image 0" descr="figuras/modelagem_analise_erro.png">    </p:cNvPr>
+          <p:cNvPicPr>
+            <a:picLocks noChangeAspect="1"/>
+          </p:cNvPicPr>
+          <p:nvPr/>
+        </p:nvPicPr>
+        <p:blipFill>
+          <a:blip r:embed="rId1"/>
+          <a:stretch>
+            <a:fillRect/>
+          </a:stretch>
+        </p:blipFill>
+        <p:spPr>
+          <a:xfrm>
+            <a:off x="1310564" y="1874520"/>
+            <a:ext cx="9540392" cy="3520440"/>
+          </a:xfrm>
+          <a:prstGeom prst="rect">
+            <a:avLst/>
+          </a:prstGeom>
+          <a:effectLst>
+            <a:outerShdw sx="100000" sy="100000" kx="0" ky="0" algn="bl" rotWithShape="0" blurRad="88900" dist="38100" dir="8100000">
+              <a:srgbClr val="000000">
+                <a:alpha val="16000"/>
+              </a:srgbClr>
+            </a:outerShdw>
+          </a:effectLst>
+        </p:spPr>
+      </p:pic>
+      <p:sp>
+        <p:nvSpPr>
+          <p:cNvPr id="6" name="Shape 3"/>
+          <p:cNvSpPr/>
+          <p:nvPr/>
+        </p:nvSpPr>
+        <p:spPr>
+          <a:xfrm>
+            <a:off x="640080" y="5577840"/>
+            <a:ext cx="10881360" cy="960120"/>
+          </a:xfrm>
+          <a:prstGeom prst="rect">
+            <a:avLst/>
+          </a:prstGeom>
+          <a:solidFill>
+            <a:srgbClr val="FBEEEC"/>
+          </a:solidFill>
+          <a:ln w="12700">
+            <a:solidFill>
+              <a:srgbClr val="C0392B"/>
+            </a:solidFill>
+            <a:prstDash val="solid"/>
+          </a:ln>
+        </p:spPr>
+      </p:sp>
       <p:sp>
         <p:nvSpPr>
           <p:cNvPr id="7" name="Text 4"/>
+          <p:cNvSpPr/>
+          <p:nvPr/>
+        </p:nvSpPr>
+        <p:spPr>
+          <a:xfrm>
+            <a:off x="868680" y="5650992"/>
+            <a:ext cx="10424160" cy="822960"/>
+          </a:xfrm>
+          <a:prstGeom prst="rect">
+            <a:avLst/>
+          </a:prstGeom>
+          <a:noFill/>
+          <a:ln/>
+        </p:spPr>
+        <p:txBody>
+          <a:bodyPr wrap="square" lIns="0" tIns="0" rIns="0" bIns="0" rtlCol="0" anchor="ctr"/>
+          <a:lstStyle/>
+          <a:p>
+            <a:pPr indent="0" marL="0">
+              <a:lnSpc>
+                <a:spcPct val="105000"/>
+              </a:lnSpc>
+              <a:buNone/>
+            </a:pPr>
+            <a:r>
+              <a:rPr lang="en-US" sz="1200" b="1" dirty="0">
+                <a:solidFill>
+                  <a:srgbClr val="C0392B"/>
+                </a:solidFill>
+                <a:latin typeface="Calibri" pitchFamily="34" charset="0"/>
+                <a:ea typeface="Calibri" pitchFamily="34" charset="-122"/>
+                <a:cs typeface="Calibri" pitchFamily="34" charset="-120"/>
+              </a:rPr>
+              <a:t>Não é bug — é a base rate.  </a:t>
+            </a:r>
+            <a:pPr indent="0" marL="0">
+              <a:lnSpc>
+                <a:spcPct val="105000"/>
+              </a:lnSpc>
+              <a:buNone/>
+            </a:pPr>
+            <a:r>
+              <a:rPr lang="en-US" sz="1200" dirty="0">
+                <a:solidFill>
+                  <a:srgbClr val="2B2B2B"/>
+                </a:solidFill>
+                <a:latin typeface="Calibri" pitchFamily="34" charset="0"/>
+                <a:ea typeface="Calibri" pitchFamily="34" charset="-122"/>
+                <a:cs typeface="Calibri" pitchFamily="34" charset="-120"/>
+              </a:rPr>
+              <a:t>Nenhum limiar supera F1≈0,24 (teto = AUC 0,63). Sem RUS a acurácia chega a 90%, mas o recall é ZERO — não identifica nenhum doente. O RUS aceita 375 falsos-positivos para enxergar 2/3 dos 99 artríticos: consequência de 10% de prevalência + sinal nutricional fraco, não do algoritmo.</a:t>
+            </a:r>
+            <a:endParaRPr lang="en-US" sz="1200" dirty="0"/>
+          </a:p>
+        </p:txBody>
+      </p:sp>
+      <p:sp>
+        <p:nvSpPr>
+          <p:cNvPr id="8" name="Text 5"/>
           <p:cNvSpPr/>
           <p:nvPr/>
         </p:nvSpPr>
@@ -17788,7 +18261,7 @@
       </p:sp>
       <p:sp>
         <p:nvSpPr>
-          <p:cNvPr id="8" name="Text 5"/>
+          <p:cNvPr id="9" name="Text 6"/>
           <p:cNvSpPr/>
           <p:nvPr/>
         </p:nvSpPr>

</xml_diff>